<commit_message>
docs: update summer classic overview deck
Co-Authored-By: Claude Sonnet 5 <noreply@anthropic.com>
</commit_message>
<xml_diff>
--- a/docs/summer-classic-overview.pptx
+++ b/docs/summer-classic-overview.pptx
@@ -65,20 +65,30 @@
             <a:noAutofit/>
           </a:bodyPr>
           <a:p>
-            <a:r>
-              <a:rPr b="0" lang="en-US" sz="1800" spc="-1" strike="noStrike">
-                <a:solidFill>
-                  <a:schemeClr val="dk1"/>
-                </a:solidFill>
-                <a:latin typeface="Calibri"/>
-              </a:rPr>
-              <a:t>Click to move the slide</a:t>
-            </a:r>
-            <a:endParaRPr b="0" lang="en-US" sz="1800" spc="-1" strike="noStrike">
-              <a:solidFill>
-                <a:schemeClr val="dk1"/>
-              </a:solidFill>
-              <a:latin typeface="Calibri"/>
+            <a:pPr algn="ctr"/>
+            <a:r>
+              <a:rPr b="0" lang="en-US" sz="4400" spc="-1" strike="noStrike">
+                <a:solidFill>
+                  <a:srgbClr val="000000"/>
+                </a:solidFill>
+                <a:latin typeface="Arial"/>
+              </a:rPr>
+              <a:t>Click to move </a:t>
+            </a:r>
+            <a:r>
+              <a:rPr b="0" lang="en-US" sz="4400" spc="-1" strike="noStrike">
+                <a:solidFill>
+                  <a:srgbClr val="000000"/>
+                </a:solidFill>
+                <a:latin typeface="Arial"/>
+              </a:rPr>
+              <a:t>the slide</a:t>
+            </a:r>
+            <a:endParaRPr b="0" lang="en-US" sz="4400" spc="-1" strike="noStrike">
+              <a:solidFill>
+                <a:srgbClr val="000000"/>
+              </a:solidFill>
+              <a:latin typeface="Arial"/>
             </a:endParaRPr>
           </a:p>
         </p:txBody>
@@ -343,7 +353,7 @@
             <a:pPr indent="0" algn="r">
               <a:buNone/>
             </a:pPr>
-            <a:fld id="{97F9524B-5616-4020-9DA1-4843D73FFE64}" type="slidenum">
+            <a:fld id="{CC21BD1F-2FC8-45A4-B908-7ACE304A914E}" type="slidenum">
               <a:rPr b="0" lang="en-US" sz="1400" spc="-1" strike="noStrike">
                 <a:solidFill>
                   <a:srgbClr val="000000"/>
@@ -397,7 +407,7 @@
         <p:spPr>
           <a:xfrm>
             <a:off x="685800" y="1143000"/>
-            <a:ext cx="5486040" cy="3085920"/>
+            <a:ext cx="5485680" cy="3085560"/>
           </a:xfrm>
           <a:prstGeom prst="rect">
             <a:avLst/>
@@ -420,7 +430,7 @@
         <p:spPr>
           <a:xfrm>
             <a:off x="685800" y="4400640"/>
-            <a:ext cx="5486040" cy="3600000"/>
+            <a:ext cx="5485680" cy="3599640"/>
           </a:xfrm>
           <a:prstGeom prst="rect">
             <a:avLst/>
@@ -460,7 +470,7 @@
         <p:spPr>
           <a:xfrm>
             <a:off x="3884760" y="8685360"/>
-            <a:ext cx="2971440" cy="458280"/>
+            <a:ext cx="2971080" cy="457920"/>
           </a:xfrm>
           <a:prstGeom prst="rect">
             <a:avLst/>
@@ -480,6 +490,9 @@
                 <a:spcPct val="100000"/>
               </a:lnSpc>
               <a:buNone/>
+              <a:tabLst>
+                <a:tab algn="l" pos="0"/>
+              </a:tabLst>
               <a:defRPr b="0" lang="en-US" sz="1200" spc="-1" strike="noStrike">
                 <a:solidFill>
                   <a:schemeClr val="dk1"/>
@@ -495,8 +508,11 @@
                 <a:spcPct val="100000"/>
               </a:lnSpc>
               <a:buNone/>
-            </a:pPr>
-            <a:fld id="{3F695200-FBD7-4FFB-B171-03DD840C68DA}" type="slidenum">
+              <a:tabLst>
+                <a:tab algn="l" pos="0"/>
+              </a:tabLst>
+            </a:pPr>
+            <a:fld id="{D8282B0B-ED57-489B-AFA4-A19EBB6435E4}" type="slidenum">
               <a:rPr b="0" lang="en-US" sz="1200" spc="-1" strike="noStrike">
                 <a:solidFill>
                   <a:schemeClr val="dk1"/>
@@ -550,7 +566,7 @@
         <p:spPr>
           <a:xfrm>
             <a:off x="685800" y="1143000"/>
-            <a:ext cx="5486040" cy="3085920"/>
+            <a:ext cx="5485680" cy="3085560"/>
           </a:xfrm>
           <a:prstGeom prst="rect">
             <a:avLst/>
@@ -573,7 +589,7 @@
         <p:spPr>
           <a:xfrm>
             <a:off x="685800" y="4400640"/>
-            <a:ext cx="5486040" cy="3600000"/>
+            <a:ext cx="5485680" cy="3599640"/>
           </a:xfrm>
           <a:prstGeom prst="rect">
             <a:avLst/>
@@ -613,7 +629,7 @@
         <p:spPr>
           <a:xfrm>
             <a:off x="3884760" y="8685360"/>
-            <a:ext cx="2971440" cy="458280"/>
+            <a:ext cx="2971080" cy="457920"/>
           </a:xfrm>
           <a:prstGeom prst="rect">
             <a:avLst/>
@@ -633,6 +649,9 @@
                 <a:spcPct val="100000"/>
               </a:lnSpc>
               <a:buNone/>
+              <a:tabLst>
+                <a:tab algn="l" pos="0"/>
+              </a:tabLst>
               <a:defRPr b="0" lang="en-US" sz="1200" spc="-1" strike="noStrike">
                 <a:solidFill>
                   <a:schemeClr val="dk1"/>
@@ -648,8 +667,11 @@
                 <a:spcPct val="100000"/>
               </a:lnSpc>
               <a:buNone/>
-            </a:pPr>
-            <a:fld id="{B121A15A-4C5C-4861-84C6-C359F7A7B518}" type="slidenum">
+              <a:tabLst>
+                <a:tab algn="l" pos="0"/>
+              </a:tabLst>
+            </a:pPr>
+            <a:fld id="{56CA8EAC-61C3-45DF-92D3-D438E61D570B}" type="slidenum">
               <a:rPr b="0" lang="en-US" sz="1200" spc="-1" strike="noStrike">
                 <a:solidFill>
                   <a:schemeClr val="dk1"/>
@@ -703,7 +725,7 @@
         <p:spPr>
           <a:xfrm>
             <a:off x="685800" y="1143000"/>
-            <a:ext cx="5486040" cy="3085920"/>
+            <a:ext cx="5485680" cy="3085560"/>
           </a:xfrm>
           <a:prstGeom prst="rect">
             <a:avLst/>
@@ -726,7 +748,7 @@
         <p:spPr>
           <a:xfrm>
             <a:off x="685800" y="4400640"/>
-            <a:ext cx="5486040" cy="3600000"/>
+            <a:ext cx="5485680" cy="3599640"/>
           </a:xfrm>
           <a:prstGeom prst="rect">
             <a:avLst/>
@@ -766,7 +788,7 @@
         <p:spPr>
           <a:xfrm>
             <a:off x="3884760" y="8685360"/>
-            <a:ext cx="2971440" cy="458280"/>
+            <a:ext cx="2971080" cy="457920"/>
           </a:xfrm>
           <a:prstGeom prst="rect">
             <a:avLst/>
@@ -786,6 +808,9 @@
                 <a:spcPct val="100000"/>
               </a:lnSpc>
               <a:buNone/>
+              <a:tabLst>
+                <a:tab algn="l" pos="0"/>
+              </a:tabLst>
               <a:defRPr b="0" lang="en-US" sz="1200" spc="-1" strike="noStrike">
                 <a:solidFill>
                   <a:schemeClr val="dk1"/>
@@ -801,8 +826,11 @@
                 <a:spcPct val="100000"/>
               </a:lnSpc>
               <a:buNone/>
-            </a:pPr>
-            <a:fld id="{D51B3B1B-9BC8-4744-A791-A80C0AD0CE1B}" type="slidenum">
+              <a:tabLst>
+                <a:tab algn="l" pos="0"/>
+              </a:tabLst>
+            </a:pPr>
+            <a:fld id="{AEDD2834-0E96-4E4E-9AB8-9D3AC3185F6B}" type="slidenum">
               <a:rPr b="0" lang="en-US" sz="1200" spc="-1" strike="noStrike">
                 <a:solidFill>
                   <a:schemeClr val="dk1"/>
@@ -856,7 +884,7 @@
         <p:spPr>
           <a:xfrm>
             <a:off x="685800" y="1143000"/>
-            <a:ext cx="5486040" cy="3085920"/>
+            <a:ext cx="5485680" cy="3085560"/>
           </a:xfrm>
           <a:prstGeom prst="rect">
             <a:avLst/>
@@ -879,7 +907,7 @@
         <p:spPr>
           <a:xfrm>
             <a:off x="685800" y="4400640"/>
-            <a:ext cx="5486040" cy="3600000"/>
+            <a:ext cx="5485680" cy="3599640"/>
           </a:xfrm>
           <a:prstGeom prst="rect">
             <a:avLst/>
@@ -919,7 +947,7 @@
         <p:spPr>
           <a:xfrm>
             <a:off x="3884760" y="8685360"/>
-            <a:ext cx="2971440" cy="458280"/>
+            <a:ext cx="2971080" cy="457920"/>
           </a:xfrm>
           <a:prstGeom prst="rect">
             <a:avLst/>
@@ -939,6 +967,9 @@
                 <a:spcPct val="100000"/>
               </a:lnSpc>
               <a:buNone/>
+              <a:tabLst>
+                <a:tab algn="l" pos="0"/>
+              </a:tabLst>
               <a:defRPr b="0" lang="en-US" sz="1200" spc="-1" strike="noStrike">
                 <a:solidFill>
                   <a:schemeClr val="dk1"/>
@@ -954,8 +985,11 @@
                 <a:spcPct val="100000"/>
               </a:lnSpc>
               <a:buNone/>
-            </a:pPr>
-            <a:fld id="{1136B020-234D-443D-8E6A-D7CCC088D313}" type="slidenum">
+              <a:tabLst>
+                <a:tab algn="l" pos="0"/>
+              </a:tabLst>
+            </a:pPr>
+            <a:fld id="{AC165D15-3CB4-4267-B0D4-9C9858E6C2AE}" type="slidenum">
               <a:rPr b="0" lang="en-US" sz="1200" spc="-1" strike="noStrike">
                 <a:solidFill>
                   <a:schemeClr val="dk1"/>
@@ -1009,7 +1043,7 @@
         <p:spPr>
           <a:xfrm>
             <a:off x="685800" y="1143000"/>
-            <a:ext cx="5486040" cy="3085920"/>
+            <a:ext cx="5485680" cy="3085560"/>
           </a:xfrm>
           <a:prstGeom prst="rect">
             <a:avLst/>
@@ -1032,7 +1066,7 @@
         <p:spPr>
           <a:xfrm>
             <a:off x="685800" y="4400640"/>
-            <a:ext cx="5486040" cy="3600000"/>
+            <a:ext cx="5485680" cy="3599640"/>
           </a:xfrm>
           <a:prstGeom prst="rect">
             <a:avLst/>
@@ -1072,7 +1106,7 @@
         <p:spPr>
           <a:xfrm>
             <a:off x="3884760" y="8685360"/>
-            <a:ext cx="2971440" cy="458280"/>
+            <a:ext cx="2971080" cy="457920"/>
           </a:xfrm>
           <a:prstGeom prst="rect">
             <a:avLst/>
@@ -1092,6 +1126,9 @@
                 <a:spcPct val="100000"/>
               </a:lnSpc>
               <a:buNone/>
+              <a:tabLst>
+                <a:tab algn="l" pos="0"/>
+              </a:tabLst>
               <a:defRPr b="0" lang="en-US" sz="1200" spc="-1" strike="noStrike">
                 <a:solidFill>
                   <a:schemeClr val="dk1"/>
@@ -1107,8 +1144,11 @@
                 <a:spcPct val="100000"/>
               </a:lnSpc>
               <a:buNone/>
-            </a:pPr>
-            <a:fld id="{4049722B-A3D4-49A2-9ED0-32F906EF7FD8}" type="slidenum">
+              <a:tabLst>
+                <a:tab algn="l" pos="0"/>
+              </a:tabLst>
+            </a:pPr>
+            <a:fld id="{EC10D36F-C5F5-446F-A5D9-59DF9723D44F}" type="slidenum">
               <a:rPr b="0" lang="en-US" sz="1200" spc="-1" strike="noStrike">
                 <a:solidFill>
                   <a:schemeClr val="dk1"/>
@@ -1162,7 +1202,7 @@
         <p:spPr>
           <a:xfrm>
             <a:off x="685800" y="1143000"/>
-            <a:ext cx="5486040" cy="3085920"/>
+            <a:ext cx="5485680" cy="3085560"/>
           </a:xfrm>
           <a:prstGeom prst="rect">
             <a:avLst/>
@@ -1185,7 +1225,7 @@
         <p:spPr>
           <a:xfrm>
             <a:off x="685800" y="4400640"/>
-            <a:ext cx="5486040" cy="3600000"/>
+            <a:ext cx="5485680" cy="3599640"/>
           </a:xfrm>
           <a:prstGeom prst="rect">
             <a:avLst/>
@@ -1225,7 +1265,7 @@
         <p:spPr>
           <a:xfrm>
             <a:off x="3884760" y="8685360"/>
-            <a:ext cx="2971440" cy="458280"/>
+            <a:ext cx="2971080" cy="457920"/>
           </a:xfrm>
           <a:prstGeom prst="rect">
             <a:avLst/>
@@ -1245,6 +1285,9 @@
                 <a:spcPct val="100000"/>
               </a:lnSpc>
               <a:buNone/>
+              <a:tabLst>
+                <a:tab algn="l" pos="0"/>
+              </a:tabLst>
               <a:defRPr b="0" lang="en-US" sz="1200" spc="-1" strike="noStrike">
                 <a:solidFill>
                   <a:schemeClr val="dk1"/>
@@ -1260,8 +1303,11 @@
                 <a:spcPct val="100000"/>
               </a:lnSpc>
               <a:buNone/>
-            </a:pPr>
-            <a:fld id="{33513730-6433-4B13-980B-3F327239F562}" type="slidenum">
+              <a:tabLst>
+                <a:tab algn="l" pos="0"/>
+              </a:tabLst>
+            </a:pPr>
+            <a:fld id="{30E7C93D-1CBE-41DD-9986-849E9386258D}" type="slidenum">
               <a:rPr b="0" lang="en-US" sz="1200" spc="-1" strike="noStrike">
                 <a:solidFill>
                   <a:schemeClr val="dk1"/>
@@ -1359,23 +1405,23 @@
             <a:noAutofit/>
           </a:bodyPr>
           <a:p>
-            <a:pPr indent="0">
+            <a:pPr indent="0" algn="ctr">
               <a:buNone/>
             </a:pPr>
             <a:r>
-              <a:rPr b="0" lang="en-US" sz="1800" spc="-1" strike="noStrike">
-                <a:solidFill>
-                  <a:schemeClr val="dk1"/>
-                </a:solidFill>
-                <a:latin typeface="Calibri"/>
+              <a:rPr b="0" lang="en-US" sz="4400" spc="-1" strike="noStrike">
+                <a:solidFill>
+                  <a:srgbClr val="000000"/>
+                </a:solidFill>
+                <a:latin typeface="Arial"/>
               </a:rPr>
               <a:t>Click to edit the title text format</a:t>
             </a:r>
-            <a:endParaRPr b="0" lang="en-US" sz="1800" spc="-1" strike="noStrike">
-              <a:solidFill>
-                <a:schemeClr val="dk1"/>
-              </a:solidFill>
-              <a:latin typeface="Calibri"/>
+            <a:endParaRPr b="0" lang="en-US" sz="4400" spc="-1" strike="noStrike">
+              <a:solidFill>
+                <a:srgbClr val="000000"/>
+              </a:solidFill>
+              <a:latin typeface="Arial"/>
             </a:endParaRPr>
           </a:p>
         </p:txBody>
@@ -1405,7 +1451,7 @@
         </p:spPr>
         <p:txBody>
           <a:bodyPr lIns="0" rIns="0" tIns="0" bIns="0" anchor="t">
-            <a:normAutofit fontScale="95303"/>
+            <a:normAutofit/>
           </a:bodyPr>
           <a:p>
             <a:pPr marL="432000" indent="-324000">
@@ -1422,17 +1468,17 @@
             <a:r>
               <a:rPr b="0" lang="en-US" sz="3200" spc="-1" strike="noStrike">
                 <a:solidFill>
-                  <a:schemeClr val="dk1"/>
-                </a:solidFill>
-                <a:latin typeface="Calibri"/>
+                  <a:srgbClr val="000000"/>
+                </a:solidFill>
+                <a:latin typeface="Arial"/>
               </a:rPr>
               <a:t>Click to edit the outline text format</a:t>
             </a:r>
             <a:endParaRPr b="0" lang="en-US" sz="3200" spc="-1" strike="noStrike">
               <a:solidFill>
-                <a:schemeClr val="dk1"/>
-              </a:solidFill>
-              <a:latin typeface="Calibri"/>
+                <a:srgbClr val="000000"/>
+              </a:solidFill>
+              <a:latin typeface="Arial"/>
             </a:endParaRPr>
           </a:p>
           <a:p>
@@ -1448,19 +1494,19 @@
               <a:buChar char=""/>
             </a:pPr>
             <a:r>
-              <a:rPr b="0" lang="en-US" sz="2400" spc="-1" strike="noStrike">
-                <a:solidFill>
-                  <a:schemeClr val="dk1"/>
-                </a:solidFill>
-                <a:latin typeface="Calibri"/>
+              <a:rPr b="0" lang="en-US" sz="2800" spc="-1" strike="noStrike">
+                <a:solidFill>
+                  <a:srgbClr val="000000"/>
+                </a:solidFill>
+                <a:latin typeface="Arial"/>
               </a:rPr>
               <a:t>Second Outline Level</a:t>
             </a:r>
-            <a:endParaRPr b="0" lang="en-US" sz="2400" spc="-1" strike="noStrike">
-              <a:solidFill>
-                <a:schemeClr val="dk1"/>
-              </a:solidFill>
-              <a:latin typeface="Calibri"/>
+            <a:endParaRPr b="0" lang="en-US" sz="2800" spc="-1" strike="noStrike">
+              <a:solidFill>
+                <a:srgbClr val="000000"/>
+              </a:solidFill>
+              <a:latin typeface="Arial"/>
             </a:endParaRPr>
           </a:p>
           <a:p>
@@ -1476,19 +1522,19 @@
               <a:buChar char=""/>
             </a:pPr>
             <a:r>
-              <a:rPr b="0" lang="en-US" sz="2000" spc="-1" strike="noStrike">
-                <a:solidFill>
-                  <a:schemeClr val="dk1"/>
-                </a:solidFill>
-                <a:latin typeface="Calibri"/>
+              <a:rPr b="0" lang="en-US" sz="2400" spc="-1" strike="noStrike">
+                <a:solidFill>
+                  <a:srgbClr val="000000"/>
+                </a:solidFill>
+                <a:latin typeface="Arial"/>
               </a:rPr>
               <a:t>Third Outline Level</a:t>
             </a:r>
-            <a:endParaRPr b="0" lang="en-US" sz="2000" spc="-1" strike="noStrike">
-              <a:solidFill>
-                <a:schemeClr val="dk1"/>
-              </a:solidFill>
-              <a:latin typeface="Calibri"/>
+            <a:endParaRPr b="0" lang="en-US" sz="2400" spc="-1" strike="noStrike">
+              <a:solidFill>
+                <a:srgbClr val="000000"/>
+              </a:solidFill>
+              <a:latin typeface="Arial"/>
             </a:endParaRPr>
           </a:p>
           <a:p>
@@ -1506,17 +1552,17 @@
             <a:r>
               <a:rPr b="0" lang="en-US" sz="2000" spc="-1" strike="noStrike">
                 <a:solidFill>
-                  <a:schemeClr val="dk1"/>
-                </a:solidFill>
-                <a:latin typeface="Calibri"/>
+                  <a:srgbClr val="000000"/>
+                </a:solidFill>
+                <a:latin typeface="Arial"/>
               </a:rPr>
               <a:t>Fourth Outline Level</a:t>
             </a:r>
             <a:endParaRPr b="0" lang="en-US" sz="2000" spc="-1" strike="noStrike">
               <a:solidFill>
-                <a:schemeClr val="dk1"/>
-              </a:solidFill>
-              <a:latin typeface="Calibri"/>
+                <a:srgbClr val="000000"/>
+              </a:solidFill>
+              <a:latin typeface="Arial"/>
             </a:endParaRPr>
           </a:p>
           <a:p>
@@ -1534,17 +1580,17 @@
             <a:r>
               <a:rPr b="0" lang="en-US" sz="2000" spc="-1" strike="noStrike">
                 <a:solidFill>
-                  <a:schemeClr val="dk1"/>
-                </a:solidFill>
-                <a:latin typeface="Calibri"/>
+                  <a:srgbClr val="000000"/>
+                </a:solidFill>
+                <a:latin typeface="Arial"/>
               </a:rPr>
               <a:t>Fifth Outline Level</a:t>
             </a:r>
             <a:endParaRPr b="0" lang="en-US" sz="2000" spc="-1" strike="noStrike">
               <a:solidFill>
-                <a:schemeClr val="dk1"/>
-              </a:solidFill>
-              <a:latin typeface="Calibri"/>
+                <a:srgbClr val="000000"/>
+              </a:solidFill>
+              <a:latin typeface="Arial"/>
             </a:endParaRPr>
           </a:p>
           <a:p>
@@ -1562,17 +1608,17 @@
             <a:r>
               <a:rPr b="0" lang="en-US" sz="2000" spc="-1" strike="noStrike">
                 <a:solidFill>
-                  <a:schemeClr val="dk1"/>
-                </a:solidFill>
-                <a:latin typeface="Calibri"/>
+                  <a:srgbClr val="000000"/>
+                </a:solidFill>
+                <a:latin typeface="Arial"/>
               </a:rPr>
               <a:t>Sixth Outline Level</a:t>
             </a:r>
             <a:endParaRPr b="0" lang="en-US" sz="2000" spc="-1" strike="noStrike">
               <a:solidFill>
-                <a:schemeClr val="dk1"/>
-              </a:solidFill>
-              <a:latin typeface="Calibri"/>
+                <a:srgbClr val="000000"/>
+              </a:solidFill>
+              <a:latin typeface="Arial"/>
             </a:endParaRPr>
           </a:p>
           <a:p>
@@ -1590,17 +1636,17 @@
             <a:r>
               <a:rPr b="0" lang="en-US" sz="2000" spc="-1" strike="noStrike">
                 <a:solidFill>
-                  <a:schemeClr val="dk1"/>
-                </a:solidFill>
-                <a:latin typeface="Calibri"/>
+                  <a:srgbClr val="000000"/>
+                </a:solidFill>
+                <a:latin typeface="Arial"/>
               </a:rPr>
               <a:t>Seventh Outline Level</a:t>
             </a:r>
             <a:endParaRPr b="0" lang="en-US" sz="2000" spc="-1" strike="noStrike">
               <a:solidFill>
-                <a:schemeClr val="dk1"/>
-              </a:solidFill>
-              <a:latin typeface="Calibri"/>
+                <a:srgbClr val="000000"/>
+              </a:solidFill>
+              <a:latin typeface="Arial"/>
             </a:endParaRPr>
           </a:p>
         </p:txBody>
@@ -1647,7 +1693,7 @@
         <p:spPr>
           <a:xfrm>
             <a:off x="0" y="0"/>
-            <a:ext cx="9143640" cy="1572480"/>
+            <a:ext cx="9143280" cy="1572120"/>
           </a:xfrm>
           <a:prstGeom prst="rect">
             <a:avLst/>
@@ -1673,6 +1719,11 @@
             <a:noAutofit/>
           </a:bodyPr>
           <a:p>
+            <a:pPr>
+              <a:lnSpc>
+                <a:spcPct val="100000"/>
+              </a:lnSpc>
+            </a:pPr>
             <a:endParaRPr b="0" lang="en-US" sz="1800" spc="-1" strike="noStrike">
               <a:solidFill>
                 <a:srgbClr val="ffffff"/>
@@ -1691,7 +1742,7 @@
         <p:spPr>
           <a:xfrm>
             <a:off x="0" y="1572840"/>
-            <a:ext cx="9143640" cy="50040"/>
+            <a:ext cx="9143280" cy="49680"/>
           </a:xfrm>
           <a:prstGeom prst="rect">
             <a:avLst/>
@@ -1717,6 +1768,11 @@
             <a:noAutofit/>
           </a:bodyPr>
           <a:p>
+            <a:pPr>
+              <a:lnSpc>
+                <a:spcPct val="100000"/>
+              </a:lnSpc>
+            </a:pPr>
             <a:endParaRPr b="0" lang="en-US" sz="1800" spc="-1" strike="noStrike">
               <a:solidFill>
                 <a:srgbClr val="000000"/>
@@ -1735,7 +1791,7 @@
         <p:spPr>
           <a:xfrm>
             <a:off x="438840" y="118800"/>
-            <a:ext cx="1371240" cy="255600"/>
+            <a:ext cx="1370880" cy="255240"/>
           </a:xfrm>
           <a:prstGeom prst="rect">
             <a:avLst/>
@@ -1765,7 +1821,7 @@
               </a:tabLst>
             </a:pPr>
             <a:r>
-              <a:rPr b="1" lang="en-US" sz="900" spc="398" strike="noStrike">
+              <a:rPr b="1" lang="en-US" sz="900" spc="395" strike="noStrike">
                 <a:solidFill>
                   <a:srgbClr val="f28f16"/>
                 </a:solidFill>
@@ -1792,7 +1848,7 @@
         <p:spPr>
           <a:xfrm>
             <a:off x="420480" y="329040"/>
-            <a:ext cx="8320680" cy="776880"/>
+            <a:ext cx="8320320" cy="776520"/>
           </a:xfrm>
           <a:prstGeom prst="rect">
             <a:avLst/>
@@ -1849,7 +1905,7 @@
         <p:spPr>
           <a:xfrm>
             <a:off x="438840" y="1134000"/>
-            <a:ext cx="8320680" cy="347040"/>
+            <a:ext cx="8320320" cy="346680"/>
           </a:xfrm>
           <a:prstGeom prst="rect">
             <a:avLst/>
@@ -1906,7 +1962,7 @@
         <p:spPr>
           <a:xfrm>
             <a:off x="402480" y="1792080"/>
-            <a:ext cx="2706120" cy="2633040"/>
+            <a:ext cx="2705760" cy="2632680"/>
           </a:xfrm>
           <a:prstGeom prst="rect">
             <a:avLst/>
@@ -1932,6 +1988,11 @@
             <a:noAutofit/>
           </a:bodyPr>
           <a:p>
+            <a:pPr>
+              <a:lnSpc>
+                <a:spcPct val="100000"/>
+              </a:lnSpc>
+            </a:pPr>
             <a:endParaRPr b="0" lang="en-US" sz="1800" spc="-1" strike="noStrike">
               <a:solidFill>
                 <a:srgbClr val="000000"/>
@@ -1950,7 +2011,7 @@
         <p:spPr>
           <a:xfrm>
             <a:off x="402480" y="1792080"/>
-            <a:ext cx="45360" cy="2633040"/>
+            <a:ext cx="45000" cy="2632680"/>
           </a:xfrm>
           <a:prstGeom prst="rect">
             <a:avLst/>
@@ -1976,6 +2037,11 @@
             <a:noAutofit/>
           </a:bodyPr>
           <a:p>
+            <a:pPr>
+              <a:lnSpc>
+                <a:spcPct val="100000"/>
+              </a:lnSpc>
+            </a:pPr>
             <a:endParaRPr b="0" lang="en-US" sz="1800" spc="-1" strike="noStrike">
               <a:solidFill>
                 <a:srgbClr val="000000"/>
@@ -1994,7 +2060,7 @@
         <p:spPr>
           <a:xfrm>
             <a:off x="530280" y="1911240"/>
-            <a:ext cx="2505240" cy="237240"/>
+            <a:ext cx="2504880" cy="236880"/>
           </a:xfrm>
           <a:prstGeom prst="rect">
             <a:avLst/>
@@ -2024,7 +2090,7 @@
               </a:tabLst>
             </a:pPr>
             <a:r>
-              <a:rPr b="1" lang="en-US" sz="850" spc="199" strike="noStrike">
+              <a:rPr b="1" lang="en-US" sz="850" spc="197" strike="noStrike">
                 <a:solidFill>
                   <a:srgbClr val="f28f16"/>
                 </a:solidFill>
@@ -2051,7 +2117,7 @@
         <p:spPr>
           <a:xfrm>
             <a:off x="530280" y="2176200"/>
-            <a:ext cx="2450160" cy="16200"/>
+            <a:ext cx="2449800" cy="15840"/>
           </a:xfrm>
           <a:prstGeom prst="rect">
             <a:avLst/>
@@ -2077,6 +2143,11 @@
             <a:noAutofit/>
           </a:bodyPr>
           <a:p>
+            <a:pPr>
+              <a:lnSpc>
+                <a:spcPct val="100000"/>
+              </a:lnSpc>
+            </a:pPr>
             <a:endParaRPr b="0" lang="en-US" sz="1800" spc="-1" strike="noStrike">
               <a:solidFill>
                 <a:srgbClr val="000000"/>
@@ -2095,7 +2166,7 @@
         <p:spPr>
           <a:xfrm>
             <a:off x="530280" y="2249280"/>
-            <a:ext cx="2505240" cy="2084400"/>
+            <a:ext cx="2504880" cy="2084040"/>
           </a:xfrm>
           <a:prstGeom prst="rect">
             <a:avLst/>
@@ -2130,7 +2201,7 @@
               <a:buChar char=""/>
             </a:pPr>
             <a:r>
-              <a:rPr b="0" lang="en-US" sz="1050" spc="-1" strike="noStrike">
+              <a:rPr b="0" lang="en-US" sz="1800" spc="-1" strike="noStrike">
                 <a:solidFill>
                   <a:srgbClr val="1a2b35"/>
                 </a:solidFill>
@@ -2139,7 +2210,7 @@
               </a:rPr>
               <a:t>Standard distance, dominant hand</a:t>
             </a:r>
-            <a:endParaRPr b="0" lang="en-US" sz="1050" spc="-1" strike="noStrike">
+            <a:endParaRPr b="0" lang="en-US" sz="1800" spc="-1" strike="noStrike">
               <a:solidFill>
                 <a:srgbClr val="000000"/>
               </a:solidFill>
@@ -2161,7 +2232,7 @@
               <a:buChar char=""/>
             </a:pPr>
             <a:r>
-              <a:rPr b="0" lang="en-US" sz="1050" spc="-1" strike="noStrike">
+              <a:rPr b="0" lang="en-US" sz="1800" spc="-1" strike="noStrike">
                 <a:solidFill>
                   <a:srgbClr val="1a2b35"/>
                 </a:solidFill>
@@ -2170,7 +2241,7 @@
               </a:rPr>
               <a:t>5 scored throws</a:t>
             </a:r>
-            <a:endParaRPr b="0" lang="en-US" sz="1050" spc="-1" strike="noStrike">
+            <a:endParaRPr b="0" lang="en-US" sz="1800" spc="-1" strike="noStrike">
               <a:solidFill>
                 <a:srgbClr val="000000"/>
               </a:solidFill>
@@ -2192,7 +2263,7 @@
               <a:buChar char=""/>
             </a:pPr>
             <a:r>
-              <a:rPr b="0" lang="en-US" sz="1050" spc="-1" strike="noStrike">
+              <a:rPr b="0" lang="en-US" sz="1800" spc="-1" strike="noStrike">
                 <a:solidFill>
                   <a:srgbClr val="1a2b35"/>
                 </a:solidFill>
@@ -2201,7 +2272,7 @@
               </a:rPr>
               <a:t>No modifications</a:t>
             </a:r>
-            <a:endParaRPr b="0" lang="en-US" sz="1050" spc="-1" strike="noStrike">
+            <a:endParaRPr b="0" lang="en-US" sz="1800" spc="-1" strike="noStrike">
               <a:solidFill>
                 <a:srgbClr val="000000"/>
               </a:solidFill>
@@ -2223,7 +2294,7 @@
               <a:buChar char=""/>
             </a:pPr>
             <a:r>
-              <a:rPr b="0" lang="en-US" sz="1050" spc="-1" strike="noStrike">
+              <a:rPr b="0" lang="en-US" sz="1800" spc="-1" strike="noStrike">
                 <a:solidFill>
                   <a:srgbClr val="1a2b35"/>
                 </a:solidFill>
@@ -2232,7 +2303,7 @@
               </a:rPr>
               <a:t>The cleanest read on baseline ability</a:t>
             </a:r>
-            <a:endParaRPr b="0" lang="en-US" sz="1050" spc="-1" strike="noStrike">
+            <a:endParaRPr b="0" lang="en-US" sz="1800" spc="-1" strike="noStrike">
               <a:solidFill>
                 <a:srgbClr val="000000"/>
               </a:solidFill>
@@ -2250,7 +2321,7 @@
         <p:spPr>
           <a:xfrm>
             <a:off x="3273480" y="1792080"/>
-            <a:ext cx="2706120" cy="2633040"/>
+            <a:ext cx="2705760" cy="2632680"/>
           </a:xfrm>
           <a:prstGeom prst="rect">
             <a:avLst/>
@@ -2276,6 +2347,11 @@
             <a:noAutofit/>
           </a:bodyPr>
           <a:p>
+            <a:pPr>
+              <a:lnSpc>
+                <a:spcPct val="100000"/>
+              </a:lnSpc>
+            </a:pPr>
             <a:endParaRPr b="0" lang="en-US" sz="1800" spc="-1" strike="noStrike">
               <a:solidFill>
                 <a:srgbClr val="000000"/>
@@ -2294,7 +2370,7 @@
         <p:spPr>
           <a:xfrm>
             <a:off x="3273480" y="1792080"/>
-            <a:ext cx="45360" cy="2633040"/>
+            <a:ext cx="45000" cy="2632680"/>
           </a:xfrm>
           <a:prstGeom prst="rect">
             <a:avLst/>
@@ -2320,6 +2396,11 @@
             <a:noAutofit/>
           </a:bodyPr>
           <a:p>
+            <a:pPr>
+              <a:lnSpc>
+                <a:spcPct val="100000"/>
+              </a:lnSpc>
+            </a:pPr>
             <a:endParaRPr b="0" lang="en-US" sz="1800" spc="-1" strike="noStrike">
               <a:solidFill>
                 <a:srgbClr val="000000"/>
@@ -2338,7 +2419,7 @@
         <p:spPr>
           <a:xfrm>
             <a:off x="3401640" y="1911240"/>
-            <a:ext cx="2505240" cy="237240"/>
+            <a:ext cx="2504880" cy="236880"/>
           </a:xfrm>
           <a:prstGeom prst="rect">
             <a:avLst/>
@@ -2368,7 +2449,7 @@
               </a:tabLst>
             </a:pPr>
             <a:r>
-              <a:rPr b="1" lang="en-US" sz="850" spc="199" strike="noStrike">
+              <a:rPr b="1" lang="en-US" sz="850" spc="197" strike="noStrike">
                 <a:solidFill>
                   <a:srgbClr val="f28f16"/>
                 </a:solidFill>
@@ -2395,7 +2476,7 @@
         <p:spPr>
           <a:xfrm>
             <a:off x="3401640" y="2176200"/>
-            <a:ext cx="2450160" cy="16200"/>
+            <a:ext cx="2449800" cy="15840"/>
           </a:xfrm>
           <a:prstGeom prst="rect">
             <a:avLst/>
@@ -2421,6 +2502,11 @@
             <a:noAutofit/>
           </a:bodyPr>
           <a:p>
+            <a:pPr>
+              <a:lnSpc>
+                <a:spcPct val="100000"/>
+              </a:lnSpc>
+            </a:pPr>
             <a:endParaRPr b="0" lang="en-US" sz="1800" spc="-1" strike="noStrike">
               <a:solidFill>
                 <a:srgbClr val="000000"/>
@@ -2439,7 +2525,7 @@
         <p:spPr>
           <a:xfrm>
             <a:off x="3401640" y="2249280"/>
-            <a:ext cx="2505240" cy="2084400"/>
+            <a:ext cx="2504880" cy="2084040"/>
           </a:xfrm>
           <a:prstGeom prst="rect">
             <a:avLst/>
@@ -2474,7 +2560,7 @@
               <a:buChar char=""/>
             </a:pPr>
             <a:r>
-              <a:rPr b="0" lang="en-US" sz="1050" spc="-1" strike="noStrike">
+              <a:rPr b="0" lang="en-US" sz="1600" spc="-1" strike="noStrike">
                 <a:solidFill>
                   <a:srgbClr val="1a2b35"/>
                 </a:solidFill>
@@ -2483,7 +2569,7 @@
               </a:rPr>
               <a:t>Non-dominant hand only</a:t>
             </a:r>
-            <a:endParaRPr b="0" lang="en-US" sz="1050" spc="-1" strike="noStrike">
+            <a:endParaRPr b="0" lang="en-US" sz="1600" spc="-1" strike="noStrike">
               <a:solidFill>
                 <a:srgbClr val="000000"/>
               </a:solidFill>
@@ -2505,7 +2591,7 @@
               <a:buChar char=""/>
             </a:pPr>
             <a:r>
-              <a:rPr b="0" lang="en-US" sz="1050" spc="-1" strike="noStrike">
+              <a:rPr b="0" lang="en-US" sz="1600" spc="-1" strike="noStrike">
                 <a:solidFill>
                   <a:srgbClr val="1a2b35"/>
                 </a:solidFill>
@@ -2514,7 +2600,7 @@
               </a:rPr>
               <a:t>5 scored throws</a:t>
             </a:r>
-            <a:endParaRPr b="0" lang="en-US" sz="1050" spc="-1" strike="noStrike">
+            <a:endParaRPr b="0" lang="en-US" sz="1600" spc="-1" strike="noStrike">
               <a:solidFill>
                 <a:srgbClr val="000000"/>
               </a:solidFill>
@@ -2536,7 +2622,7 @@
               <a:buChar char=""/>
             </a:pPr>
             <a:r>
-              <a:rPr b="0" lang="en-US" sz="1050" spc="-1" strike="noStrike">
+              <a:rPr b="0" lang="en-US" sz="1600" spc="-1" strike="noStrike">
                 <a:solidFill>
                   <a:srgbClr val="1a2b35"/>
                 </a:solidFill>
@@ -2545,7 +2631,7 @@
               </a:rPr>
               <a:t>Consistency data and a documented floor</a:t>
             </a:r>
-            <a:endParaRPr b="0" lang="en-US" sz="1050" spc="-1" strike="noStrike">
+            <a:endParaRPr b="0" lang="en-US" sz="1600" spc="-1" strike="noStrike">
               <a:solidFill>
                 <a:srgbClr val="000000"/>
               </a:solidFill>
@@ -2567,7 +2653,7 @@
               <a:buChar char=""/>
             </a:pPr>
             <a:r>
-              <a:rPr b="0" lang="en-US" sz="1050" spc="-1" strike="noStrike">
+              <a:rPr b="0" lang="en-US" sz="1600" spc="-1" strike="noStrike">
                 <a:solidFill>
                   <a:srgbClr val="1a2b35"/>
                 </a:solidFill>
@@ -2576,7 +2662,7 @@
               </a:rPr>
               <a:t>Low scores expected — that's the point</a:t>
             </a:r>
-            <a:endParaRPr b="0" lang="en-US" sz="1050" spc="-1" strike="noStrike">
+            <a:endParaRPr b="0" lang="en-US" sz="1600" spc="-1" strike="noStrike">
               <a:solidFill>
                 <a:srgbClr val="000000"/>
               </a:solidFill>
@@ -2594,7 +2680,7 @@
         <p:spPr>
           <a:xfrm>
             <a:off x="6144840" y="1792080"/>
-            <a:ext cx="2706120" cy="2633040"/>
+            <a:ext cx="2705760" cy="2632680"/>
           </a:xfrm>
           <a:prstGeom prst="rect">
             <a:avLst/>
@@ -2620,6 +2706,11 @@
             <a:noAutofit/>
           </a:bodyPr>
           <a:p>
+            <a:pPr>
+              <a:lnSpc>
+                <a:spcPct val="100000"/>
+              </a:lnSpc>
+            </a:pPr>
             <a:endParaRPr b="0" lang="en-US" sz="1800" spc="-1" strike="noStrike">
               <a:solidFill>
                 <a:srgbClr val="000000"/>
@@ -2638,7 +2729,7 @@
         <p:spPr>
           <a:xfrm>
             <a:off x="6144840" y="1792080"/>
-            <a:ext cx="45360" cy="2633040"/>
+            <a:ext cx="45000" cy="2632680"/>
           </a:xfrm>
           <a:prstGeom prst="rect">
             <a:avLst/>
@@ -2664,6 +2755,11 @@
             <a:noAutofit/>
           </a:bodyPr>
           <a:p>
+            <a:pPr>
+              <a:lnSpc>
+                <a:spcPct val="100000"/>
+              </a:lnSpc>
+            </a:pPr>
             <a:endParaRPr b="0" lang="en-US" sz="1800" spc="-1" strike="noStrike">
               <a:solidFill>
                 <a:srgbClr val="000000"/>
@@ -2682,7 +2778,7 @@
         <p:spPr>
           <a:xfrm>
             <a:off x="6272640" y="1911240"/>
-            <a:ext cx="2505240" cy="237240"/>
+            <a:ext cx="2504880" cy="236880"/>
           </a:xfrm>
           <a:prstGeom prst="rect">
             <a:avLst/>
@@ -2712,7 +2808,7 @@
               </a:tabLst>
             </a:pPr>
             <a:r>
-              <a:rPr b="1" lang="en-US" sz="850" spc="199" strike="noStrike">
+              <a:rPr b="1" lang="en-US" sz="850" spc="197" strike="noStrike">
                 <a:solidFill>
                   <a:srgbClr val="f28f16"/>
                 </a:solidFill>
@@ -2739,7 +2835,7 @@
         <p:spPr>
           <a:xfrm>
             <a:off x="6272640" y="2176200"/>
-            <a:ext cx="2450160" cy="16200"/>
+            <a:ext cx="2449800" cy="15840"/>
           </a:xfrm>
           <a:prstGeom prst="rect">
             <a:avLst/>
@@ -2765,6 +2861,11 @@
             <a:noAutofit/>
           </a:bodyPr>
           <a:p>
+            <a:pPr>
+              <a:lnSpc>
+                <a:spcPct val="100000"/>
+              </a:lnSpc>
+            </a:pPr>
             <a:endParaRPr b="0" lang="en-US" sz="1800" spc="-1" strike="noStrike">
               <a:solidFill>
                 <a:srgbClr val="000000"/>
@@ -2783,7 +2884,7 @@
         <p:spPr>
           <a:xfrm>
             <a:off x="6272640" y="2249280"/>
-            <a:ext cx="2505240" cy="2084400"/>
+            <a:ext cx="2504880" cy="2084040"/>
           </a:xfrm>
           <a:prstGeom prst="rect">
             <a:avLst/>
@@ -2818,7 +2919,7 @@
               <a:buChar char=""/>
             </a:pPr>
             <a:r>
-              <a:rPr b="0" lang="en-US" sz="1050" spc="-1" strike="noStrike">
+              <a:rPr b="0" lang="en-US" sz="1600" spc="-1" strike="noStrike">
                 <a:solidFill>
                   <a:srgbClr val="1a2b35"/>
                 </a:solidFill>
@@ -2827,7 +2928,7 @@
               </a:rPr>
               <a:t>Season's designated variation</a:t>
             </a:r>
-            <a:endParaRPr b="0" lang="en-US" sz="1050" spc="-1" strike="noStrike">
+            <a:endParaRPr b="0" lang="en-US" sz="1600" spc="-1" strike="noStrike">
               <a:solidFill>
                 <a:srgbClr val="000000"/>
               </a:solidFill>
@@ -2849,7 +2950,7 @@
               <a:buChar char=""/>
             </a:pPr>
             <a:r>
-              <a:rPr b="0" lang="en-US" sz="1050" spc="-1" strike="noStrike">
+              <a:rPr b="0" lang="en-US" sz="1600" spc="-1" strike="noStrike">
                 <a:solidFill>
                   <a:srgbClr val="1a2b35"/>
                 </a:solidFill>
@@ -2858,7 +2959,7 @@
               </a:rPr>
               <a:t>Coached demo first, then practice reps</a:t>
             </a:r>
-            <a:endParaRPr b="0" lang="en-US" sz="1050" spc="-1" strike="noStrike">
+            <a:endParaRPr b="0" lang="en-US" sz="1600" spc="-1" strike="noStrike">
               <a:solidFill>
                 <a:srgbClr val="000000"/>
               </a:solidFill>
@@ -2880,7 +2981,7 @@
               <a:buChar char=""/>
             </a:pPr>
             <a:r>
-              <a:rPr b="0" lang="en-US" sz="1050" spc="-1" strike="noStrike">
+              <a:rPr b="0" lang="en-US" sz="1600" spc="-1" strike="noStrike">
                 <a:solidFill>
                   <a:srgbClr val="1a2b35"/>
                 </a:solidFill>
@@ -2889,7 +2990,7 @@
               </a:rPr>
               <a:t>5 scored throws — first scored attempt of the season</a:t>
             </a:r>
-            <a:endParaRPr b="0" lang="en-US" sz="1050" spc="-1" strike="noStrike">
+            <a:endParaRPr b="0" lang="en-US" sz="1600" spc="-1" strike="noStrike">
               <a:solidFill>
                 <a:srgbClr val="000000"/>
               </a:solidFill>
@@ -2907,7 +3008,7 @@
         <p:spPr>
           <a:xfrm>
             <a:off x="0" y="4736520"/>
-            <a:ext cx="9143640" cy="406440"/>
+            <a:ext cx="9143280" cy="406080"/>
           </a:xfrm>
           <a:prstGeom prst="rect">
             <a:avLst/>
@@ -2933,6 +3034,11 @@
             <a:noAutofit/>
           </a:bodyPr>
           <a:p>
+            <a:pPr>
+              <a:lnSpc>
+                <a:spcPct val="100000"/>
+              </a:lnSpc>
+            </a:pPr>
             <a:endParaRPr b="0" lang="en-US" sz="1800" spc="-1" strike="noStrike">
               <a:solidFill>
                 <a:srgbClr val="ffffff"/>
@@ -2988,7 +3094,7 @@
         <p:spPr>
           <a:xfrm>
             <a:off x="0" y="0"/>
-            <a:ext cx="9143640" cy="1572480"/>
+            <a:ext cx="9143280" cy="1572120"/>
           </a:xfrm>
           <a:prstGeom prst="rect">
             <a:avLst/>
@@ -3014,6 +3120,11 @@
             <a:noAutofit/>
           </a:bodyPr>
           <a:p>
+            <a:pPr>
+              <a:lnSpc>
+                <a:spcPct val="100000"/>
+              </a:lnSpc>
+            </a:pPr>
             <a:endParaRPr b="0" lang="en-US" sz="1800" spc="-1" strike="noStrike">
               <a:solidFill>
                 <a:srgbClr val="ffffff"/>
@@ -3032,7 +3143,7 @@
         <p:spPr>
           <a:xfrm>
             <a:off x="0" y="1572840"/>
-            <a:ext cx="9143640" cy="50040"/>
+            <a:ext cx="9143280" cy="49680"/>
           </a:xfrm>
           <a:prstGeom prst="rect">
             <a:avLst/>
@@ -3058,6 +3169,11 @@
             <a:noAutofit/>
           </a:bodyPr>
           <a:p>
+            <a:pPr>
+              <a:lnSpc>
+                <a:spcPct val="100000"/>
+              </a:lnSpc>
+            </a:pPr>
             <a:endParaRPr b="0" lang="en-US" sz="1800" spc="-1" strike="noStrike">
               <a:solidFill>
                 <a:srgbClr val="000000"/>
@@ -3076,7 +3192,7 @@
         <p:spPr>
           <a:xfrm>
             <a:off x="438840" y="118800"/>
-            <a:ext cx="1371240" cy="255600"/>
+            <a:ext cx="1370880" cy="255240"/>
           </a:xfrm>
           <a:prstGeom prst="rect">
             <a:avLst/>
@@ -3106,7 +3222,7 @@
               </a:tabLst>
             </a:pPr>
             <a:r>
-              <a:rPr b="1" lang="en-US" sz="900" spc="398" strike="noStrike">
+              <a:rPr b="1" lang="en-US" sz="900" spc="395" strike="noStrike">
                 <a:solidFill>
                   <a:srgbClr val="f28f16"/>
                 </a:solidFill>
@@ -3133,7 +3249,7 @@
         <p:spPr>
           <a:xfrm>
             <a:off x="420480" y="329040"/>
-            <a:ext cx="8320680" cy="776880"/>
+            <a:ext cx="8320320" cy="776520"/>
           </a:xfrm>
           <a:prstGeom prst="rect">
             <a:avLst/>
@@ -3190,7 +3306,7 @@
         <p:spPr>
           <a:xfrm>
             <a:off x="438840" y="1134000"/>
-            <a:ext cx="8320680" cy="347040"/>
+            <a:ext cx="8320320" cy="346680"/>
           </a:xfrm>
           <a:prstGeom prst="rect">
             <a:avLst/>
@@ -3247,7 +3363,7 @@
         <p:spPr>
           <a:xfrm>
             <a:off x="402480" y="1783080"/>
-            <a:ext cx="4160160" cy="1389600"/>
+            <a:ext cx="4159800" cy="1389240"/>
           </a:xfrm>
           <a:prstGeom prst="rect">
             <a:avLst/>
@@ -3273,6 +3389,11 @@
             <a:noAutofit/>
           </a:bodyPr>
           <a:p>
+            <a:pPr>
+              <a:lnSpc>
+                <a:spcPct val="100000"/>
+              </a:lnSpc>
+            </a:pPr>
             <a:endParaRPr b="0" lang="en-US" sz="1800" spc="-1" strike="noStrike">
               <a:solidFill>
                 <a:srgbClr val="000000"/>
@@ -3291,7 +3412,7 @@
         <p:spPr>
           <a:xfrm>
             <a:off x="402480" y="1783080"/>
-            <a:ext cx="45360" cy="1389600"/>
+            <a:ext cx="45000" cy="1389240"/>
           </a:xfrm>
           <a:prstGeom prst="rect">
             <a:avLst/>
@@ -3317,6 +3438,11 @@
             <a:noAutofit/>
           </a:bodyPr>
           <a:p>
+            <a:pPr>
+              <a:lnSpc>
+                <a:spcPct val="100000"/>
+              </a:lnSpc>
+            </a:pPr>
             <a:endParaRPr b="0" lang="en-US" sz="1800" spc="-1" strike="noStrike">
               <a:solidFill>
                 <a:srgbClr val="000000"/>
@@ -3335,7 +3461,7 @@
         <p:spPr>
           <a:xfrm>
             <a:off x="530280" y="1901880"/>
-            <a:ext cx="3958920" cy="237240"/>
+            <a:ext cx="3958560" cy="236880"/>
           </a:xfrm>
           <a:prstGeom prst="rect">
             <a:avLst/>
@@ -3365,7 +3491,7 @@
               </a:tabLst>
             </a:pPr>
             <a:r>
-              <a:rPr b="1" lang="en-US" sz="850" spc="199" strike="noStrike">
+              <a:rPr b="1" lang="en-US" sz="850" spc="197" strike="noStrike">
                 <a:solidFill>
                   <a:srgbClr val="f28f16"/>
                 </a:solidFill>
@@ -3392,7 +3518,7 @@
         <p:spPr>
           <a:xfrm>
             <a:off x="530280" y="2167200"/>
-            <a:ext cx="3904200" cy="16200"/>
+            <a:ext cx="3903840" cy="15840"/>
           </a:xfrm>
           <a:prstGeom prst="rect">
             <a:avLst/>
@@ -3418,6 +3544,11 @@
             <a:noAutofit/>
           </a:bodyPr>
           <a:p>
+            <a:pPr>
+              <a:lnSpc>
+                <a:spcPct val="100000"/>
+              </a:lnSpc>
+            </a:pPr>
             <a:endParaRPr b="0" lang="en-US" sz="1800" spc="-1" strike="noStrike">
               <a:solidFill>
                 <a:srgbClr val="000000"/>
@@ -3436,7 +3567,7 @@
         <p:spPr>
           <a:xfrm>
             <a:off x="530280" y="2240280"/>
-            <a:ext cx="3958920" cy="840960"/>
+            <a:ext cx="3958560" cy="840600"/>
           </a:xfrm>
           <a:prstGeom prst="rect">
             <a:avLst/>
@@ -3591,7 +3722,7 @@
         <p:spPr>
           <a:xfrm>
             <a:off x="4727520" y="1783080"/>
-            <a:ext cx="4041360" cy="1389600"/>
+            <a:ext cx="4041000" cy="1389240"/>
           </a:xfrm>
           <a:prstGeom prst="rect">
             <a:avLst/>
@@ -3617,6 +3748,11 @@
             <a:noAutofit/>
           </a:bodyPr>
           <a:p>
+            <a:pPr>
+              <a:lnSpc>
+                <a:spcPct val="100000"/>
+              </a:lnSpc>
+            </a:pPr>
             <a:endParaRPr b="0" lang="en-US" sz="1800" spc="-1" strike="noStrike">
               <a:solidFill>
                 <a:srgbClr val="000000"/>
@@ -3635,7 +3771,7 @@
         <p:spPr>
           <a:xfrm>
             <a:off x="4727520" y="1783080"/>
-            <a:ext cx="45360" cy="1389600"/>
+            <a:ext cx="45000" cy="1389240"/>
           </a:xfrm>
           <a:prstGeom prst="rect">
             <a:avLst/>
@@ -3661,6 +3797,11 @@
             <a:noAutofit/>
           </a:bodyPr>
           <a:p>
+            <a:pPr>
+              <a:lnSpc>
+                <a:spcPct val="100000"/>
+              </a:lnSpc>
+            </a:pPr>
             <a:endParaRPr b="0" lang="en-US" sz="1800" spc="-1" strike="noStrike">
               <a:solidFill>
                 <a:srgbClr val="000000"/>
@@ -3679,7 +3820,7 @@
         <p:spPr>
           <a:xfrm>
             <a:off x="4855320" y="1901880"/>
-            <a:ext cx="3840120" cy="237240"/>
+            <a:ext cx="3839760" cy="236880"/>
           </a:xfrm>
           <a:prstGeom prst="rect">
             <a:avLst/>
@@ -3709,7 +3850,7 @@
               </a:tabLst>
             </a:pPr>
             <a:r>
-              <a:rPr b="1" lang="en-US" sz="850" spc="199" strike="noStrike">
+              <a:rPr b="1" lang="en-US" sz="850" spc="197" strike="noStrike">
                 <a:solidFill>
                   <a:srgbClr val="f28f16"/>
                 </a:solidFill>
@@ -3736,7 +3877,7 @@
         <p:spPr>
           <a:xfrm>
             <a:off x="4855320" y="2167200"/>
-            <a:ext cx="3785400" cy="16200"/>
+            <a:ext cx="3785040" cy="15840"/>
           </a:xfrm>
           <a:prstGeom prst="rect">
             <a:avLst/>
@@ -3762,6 +3903,11 @@
             <a:noAutofit/>
           </a:bodyPr>
           <a:p>
+            <a:pPr>
+              <a:lnSpc>
+                <a:spcPct val="100000"/>
+              </a:lnSpc>
+            </a:pPr>
             <a:endParaRPr b="0" lang="en-US" sz="1800" spc="-1" strike="noStrike">
               <a:solidFill>
                 <a:srgbClr val="000000"/>
@@ -3780,7 +3926,7 @@
         <p:spPr>
           <a:xfrm>
             <a:off x="4855320" y="2240280"/>
-            <a:ext cx="3840120" cy="840960"/>
+            <a:ext cx="3839760" cy="840600"/>
           </a:xfrm>
           <a:prstGeom prst="rect">
             <a:avLst/>
@@ -3904,7 +4050,7 @@
         <p:spPr>
           <a:xfrm>
             <a:off x="402480" y="3264480"/>
-            <a:ext cx="2541600" cy="1471680"/>
+            <a:ext cx="2541240" cy="1471320"/>
           </a:xfrm>
           <a:prstGeom prst="rect">
             <a:avLst/>
@@ -3930,6 +4076,11 @@
             <a:noAutofit/>
           </a:bodyPr>
           <a:p>
+            <a:pPr>
+              <a:lnSpc>
+                <a:spcPct val="100000"/>
+              </a:lnSpc>
+            </a:pPr>
             <a:endParaRPr b="0" lang="en-US" sz="1800" spc="-1" strike="noStrike">
               <a:solidFill>
                 <a:srgbClr val="000000"/>
@@ -3948,7 +4099,7 @@
         <p:spPr>
           <a:xfrm>
             <a:off x="402480" y="3264480"/>
-            <a:ext cx="45360" cy="1471680"/>
+            <a:ext cx="45000" cy="1471320"/>
           </a:xfrm>
           <a:prstGeom prst="rect">
             <a:avLst/>
@@ -3974,6 +4125,11 @@
             <a:noAutofit/>
           </a:bodyPr>
           <a:p>
+            <a:pPr>
+              <a:lnSpc>
+                <a:spcPct val="100000"/>
+              </a:lnSpc>
+            </a:pPr>
             <a:endParaRPr b="0" lang="en-US" sz="1800" spc="-1" strike="noStrike">
               <a:solidFill>
                 <a:srgbClr val="000000"/>
@@ -3992,7 +4148,7 @@
         <p:spPr>
           <a:xfrm>
             <a:off x="530280" y="3383280"/>
-            <a:ext cx="2340360" cy="237240"/>
+            <a:ext cx="2340000" cy="236880"/>
           </a:xfrm>
           <a:prstGeom prst="rect">
             <a:avLst/>
@@ -4022,7 +4178,7 @@
               </a:tabLst>
             </a:pPr>
             <a:r>
-              <a:rPr b="1" lang="en-US" sz="850" spc="199" strike="noStrike">
+              <a:rPr b="1" lang="en-US" sz="850" spc="197" strike="noStrike">
                 <a:solidFill>
                   <a:srgbClr val="f28f16"/>
                 </a:solidFill>
@@ -4049,7 +4205,7 @@
         <p:spPr>
           <a:xfrm>
             <a:off x="530280" y="3648600"/>
-            <a:ext cx="2285640" cy="16200"/>
+            <a:ext cx="2285280" cy="15840"/>
           </a:xfrm>
           <a:prstGeom prst="rect">
             <a:avLst/>
@@ -4075,6 +4231,11 @@
             <a:noAutofit/>
           </a:bodyPr>
           <a:p>
+            <a:pPr>
+              <a:lnSpc>
+                <a:spcPct val="100000"/>
+              </a:lnSpc>
+            </a:pPr>
             <a:endParaRPr b="0" lang="en-US" sz="1800" spc="-1" strike="noStrike">
               <a:solidFill>
                 <a:srgbClr val="000000"/>
@@ -4093,7 +4254,7 @@
         <p:spPr>
           <a:xfrm>
             <a:off x="530280" y="3721680"/>
-            <a:ext cx="2340360" cy="923040"/>
+            <a:ext cx="2340000" cy="922680"/>
           </a:xfrm>
           <a:prstGeom prst="rect">
             <a:avLst/>
@@ -4248,7 +4409,7 @@
         <p:spPr>
           <a:xfrm>
             <a:off x="3035880" y="3264480"/>
-            <a:ext cx="2815920" cy="1471680"/>
+            <a:ext cx="2815560" cy="1471320"/>
           </a:xfrm>
           <a:prstGeom prst="rect">
             <a:avLst/>
@@ -4274,6 +4435,11 @@
             <a:noAutofit/>
           </a:bodyPr>
           <a:p>
+            <a:pPr>
+              <a:lnSpc>
+                <a:spcPct val="100000"/>
+              </a:lnSpc>
+            </a:pPr>
             <a:endParaRPr b="0" lang="en-US" sz="1800" spc="-1" strike="noStrike">
               <a:solidFill>
                 <a:srgbClr val="000000"/>
@@ -4292,7 +4458,7 @@
         <p:spPr>
           <a:xfrm>
             <a:off x="3035880" y="3264480"/>
-            <a:ext cx="45360" cy="1471680"/>
+            <a:ext cx="45000" cy="1471320"/>
           </a:xfrm>
           <a:prstGeom prst="rect">
             <a:avLst/>
@@ -4318,6 +4484,11 @@
             <a:noAutofit/>
           </a:bodyPr>
           <a:p>
+            <a:pPr>
+              <a:lnSpc>
+                <a:spcPct val="100000"/>
+              </a:lnSpc>
+            </a:pPr>
             <a:endParaRPr b="0" lang="en-US" sz="1800" spc="-1" strike="noStrike">
               <a:solidFill>
                 <a:srgbClr val="000000"/>
@@ -4336,7 +4507,7 @@
         <p:spPr>
           <a:xfrm>
             <a:off x="3163680" y="3383280"/>
-            <a:ext cx="2614680" cy="237240"/>
+            <a:ext cx="2614320" cy="236880"/>
           </a:xfrm>
           <a:prstGeom prst="rect">
             <a:avLst/>
@@ -4366,7 +4537,7 @@
               </a:tabLst>
             </a:pPr>
             <a:r>
-              <a:rPr b="1" lang="en-US" sz="850" spc="199" strike="noStrike">
+              <a:rPr b="1" lang="en-US" sz="850" spc="197" strike="noStrike">
                 <a:solidFill>
                   <a:srgbClr val="f28f16"/>
                 </a:solidFill>
@@ -4393,7 +4564,7 @@
         <p:spPr>
           <a:xfrm>
             <a:off x="3163680" y="3648600"/>
-            <a:ext cx="2559960" cy="16200"/>
+            <a:ext cx="2559600" cy="15840"/>
           </a:xfrm>
           <a:prstGeom prst="rect">
             <a:avLst/>
@@ -4419,6 +4590,11 @@
             <a:noAutofit/>
           </a:bodyPr>
           <a:p>
+            <a:pPr>
+              <a:lnSpc>
+                <a:spcPct val="100000"/>
+              </a:lnSpc>
+            </a:pPr>
             <a:endParaRPr b="0" lang="en-US" sz="1800" spc="-1" strike="noStrike">
               <a:solidFill>
                 <a:srgbClr val="000000"/>
@@ -4437,7 +4613,7 @@
         <p:spPr>
           <a:xfrm>
             <a:off x="3163680" y="3721680"/>
-            <a:ext cx="2614680" cy="923040"/>
+            <a:ext cx="2614320" cy="922680"/>
           </a:xfrm>
           <a:prstGeom prst="rect">
             <a:avLst/>
@@ -4561,7 +4737,7 @@
         <p:spPr>
           <a:xfrm>
             <a:off x="5943600" y="3264480"/>
-            <a:ext cx="2825280" cy="1471680"/>
+            <a:ext cx="2824920" cy="1471320"/>
           </a:xfrm>
           <a:prstGeom prst="rect">
             <a:avLst/>
@@ -4587,6 +4763,11 @@
             <a:noAutofit/>
           </a:bodyPr>
           <a:p>
+            <a:pPr>
+              <a:lnSpc>
+                <a:spcPct val="100000"/>
+              </a:lnSpc>
+            </a:pPr>
             <a:endParaRPr b="0" lang="en-US" sz="1800" spc="-1" strike="noStrike">
               <a:solidFill>
                 <a:srgbClr val="000000"/>
@@ -4605,7 +4786,7 @@
         <p:spPr>
           <a:xfrm>
             <a:off x="5943600" y="3264480"/>
-            <a:ext cx="45360" cy="1471680"/>
+            <a:ext cx="45000" cy="1471320"/>
           </a:xfrm>
           <a:prstGeom prst="rect">
             <a:avLst/>
@@ -4631,6 +4812,11 @@
             <a:noAutofit/>
           </a:bodyPr>
           <a:p>
+            <a:pPr>
+              <a:lnSpc>
+                <a:spcPct val="100000"/>
+              </a:lnSpc>
+            </a:pPr>
             <a:endParaRPr b="0" lang="en-US" sz="1800" spc="-1" strike="noStrike">
               <a:solidFill>
                 <a:srgbClr val="000000"/>
@@ -4649,7 +4835,7 @@
         <p:spPr>
           <a:xfrm>
             <a:off x="6071760" y="3383280"/>
-            <a:ext cx="2624040" cy="237240"/>
+            <a:ext cx="2623680" cy="236880"/>
           </a:xfrm>
           <a:prstGeom prst="rect">
             <a:avLst/>
@@ -4679,7 +4865,7 @@
               </a:tabLst>
             </a:pPr>
             <a:r>
-              <a:rPr b="1" lang="en-US" sz="850" spc="199" strike="noStrike">
+              <a:rPr b="1" lang="en-US" sz="850" spc="197" strike="noStrike">
                 <a:solidFill>
                   <a:srgbClr val="f28f16"/>
                 </a:solidFill>
@@ -4706,7 +4892,7 @@
         <p:spPr>
           <a:xfrm>
             <a:off x="6071760" y="3648600"/>
-            <a:ext cx="2568960" cy="16200"/>
+            <a:ext cx="2568600" cy="15840"/>
           </a:xfrm>
           <a:prstGeom prst="rect">
             <a:avLst/>
@@ -4732,6 +4918,11 @@
             <a:noAutofit/>
           </a:bodyPr>
           <a:p>
+            <a:pPr>
+              <a:lnSpc>
+                <a:spcPct val="100000"/>
+              </a:lnSpc>
+            </a:pPr>
             <a:endParaRPr b="0" lang="en-US" sz="1800" spc="-1" strike="noStrike">
               <a:solidFill>
                 <a:srgbClr val="000000"/>
@@ -4750,7 +4941,7 @@
         <p:spPr>
           <a:xfrm>
             <a:off x="6071760" y="3721680"/>
-            <a:ext cx="2624040" cy="923040"/>
+            <a:ext cx="2623680" cy="922680"/>
           </a:xfrm>
           <a:prstGeom prst="rect">
             <a:avLst/>
@@ -4911,7 +5102,7 @@
         <p:spPr>
           <a:xfrm>
             <a:off x="0" y="0"/>
-            <a:ext cx="9143640" cy="1572480"/>
+            <a:ext cx="9143280" cy="1572120"/>
           </a:xfrm>
           <a:prstGeom prst="rect">
             <a:avLst/>
@@ -4937,6 +5128,11 @@
             <a:noAutofit/>
           </a:bodyPr>
           <a:p>
+            <a:pPr>
+              <a:lnSpc>
+                <a:spcPct val="100000"/>
+              </a:lnSpc>
+            </a:pPr>
             <a:endParaRPr b="0" lang="en-US" sz="1800" spc="-1" strike="noStrike">
               <a:solidFill>
                 <a:srgbClr val="ffffff"/>
@@ -4955,7 +5151,7 @@
         <p:spPr>
           <a:xfrm>
             <a:off x="0" y="1572840"/>
-            <a:ext cx="9143640" cy="50040"/>
+            <a:ext cx="9143280" cy="49680"/>
           </a:xfrm>
           <a:prstGeom prst="rect">
             <a:avLst/>
@@ -4981,6 +5177,11 @@
             <a:noAutofit/>
           </a:bodyPr>
           <a:p>
+            <a:pPr>
+              <a:lnSpc>
+                <a:spcPct val="100000"/>
+              </a:lnSpc>
+            </a:pPr>
             <a:endParaRPr b="0" lang="en-US" sz="1800" spc="-1" strike="noStrike">
               <a:solidFill>
                 <a:srgbClr val="000000"/>
@@ -4999,7 +5200,7 @@
         <p:spPr>
           <a:xfrm>
             <a:off x="438840" y="118800"/>
-            <a:ext cx="1371240" cy="255600"/>
+            <a:ext cx="1370880" cy="255240"/>
           </a:xfrm>
           <a:prstGeom prst="rect">
             <a:avLst/>
@@ -5029,7 +5230,7 @@
               </a:tabLst>
             </a:pPr>
             <a:r>
-              <a:rPr b="1" lang="en-US" sz="900" spc="398" strike="noStrike">
+              <a:rPr b="1" lang="en-US" sz="900" spc="395" strike="noStrike">
                 <a:solidFill>
                   <a:srgbClr val="f28f16"/>
                 </a:solidFill>
@@ -5056,7 +5257,7 @@
         <p:spPr>
           <a:xfrm>
             <a:off x="420480" y="329040"/>
-            <a:ext cx="8320680" cy="776880"/>
+            <a:ext cx="8320320" cy="776520"/>
           </a:xfrm>
           <a:prstGeom prst="rect">
             <a:avLst/>
@@ -5113,7 +5314,7 @@
         <p:spPr>
           <a:xfrm>
             <a:off x="438840" y="1134000"/>
-            <a:ext cx="8320680" cy="347040"/>
+            <a:ext cx="8320320" cy="346680"/>
           </a:xfrm>
           <a:prstGeom prst="rect">
             <a:avLst/>
@@ -5170,7 +5371,7 @@
         <p:spPr>
           <a:xfrm>
             <a:off x="402480" y="1783080"/>
-            <a:ext cx="4160160" cy="1425960"/>
+            <a:ext cx="4159800" cy="1425600"/>
           </a:xfrm>
           <a:prstGeom prst="rect">
             <a:avLst/>
@@ -5196,6 +5397,11 @@
             <a:noAutofit/>
           </a:bodyPr>
           <a:p>
+            <a:pPr>
+              <a:lnSpc>
+                <a:spcPct val="100000"/>
+              </a:lnSpc>
+            </a:pPr>
             <a:endParaRPr b="0" lang="en-US" sz="1800" spc="-1" strike="noStrike">
               <a:solidFill>
                 <a:srgbClr val="000000"/>
@@ -5214,7 +5420,7 @@
         <p:spPr>
           <a:xfrm>
             <a:off x="402480" y="1783080"/>
-            <a:ext cx="45360" cy="1425960"/>
+            <a:ext cx="45000" cy="1425600"/>
           </a:xfrm>
           <a:prstGeom prst="rect">
             <a:avLst/>
@@ -5240,6 +5446,11 @@
             <a:noAutofit/>
           </a:bodyPr>
           <a:p>
+            <a:pPr>
+              <a:lnSpc>
+                <a:spcPct val="100000"/>
+              </a:lnSpc>
+            </a:pPr>
             <a:endParaRPr b="0" lang="en-US" sz="1800" spc="-1" strike="noStrike">
               <a:solidFill>
                 <a:srgbClr val="000000"/>
@@ -5258,7 +5469,7 @@
         <p:spPr>
           <a:xfrm>
             <a:off x="530280" y="1901880"/>
-            <a:ext cx="3958920" cy="237240"/>
+            <a:ext cx="3958560" cy="236880"/>
           </a:xfrm>
           <a:prstGeom prst="rect">
             <a:avLst/>
@@ -5288,7 +5499,7 @@
               </a:tabLst>
             </a:pPr>
             <a:r>
-              <a:rPr b="1" lang="en-US" sz="850" spc="199" strike="noStrike">
+              <a:rPr b="1" lang="en-US" sz="850" spc="197" strike="noStrike">
                 <a:solidFill>
                   <a:srgbClr val="f28f16"/>
                 </a:solidFill>
@@ -5315,7 +5526,7 @@
         <p:spPr>
           <a:xfrm>
             <a:off x="530280" y="2167200"/>
-            <a:ext cx="3904200" cy="16200"/>
+            <a:ext cx="3903840" cy="15840"/>
           </a:xfrm>
           <a:prstGeom prst="rect">
             <a:avLst/>
@@ -5341,6 +5552,11 @@
             <a:noAutofit/>
           </a:bodyPr>
           <a:p>
+            <a:pPr>
+              <a:lnSpc>
+                <a:spcPct val="100000"/>
+              </a:lnSpc>
+            </a:pPr>
             <a:endParaRPr b="0" lang="en-US" sz="1800" spc="-1" strike="noStrike">
               <a:solidFill>
                 <a:srgbClr val="000000"/>
@@ -5359,7 +5575,7 @@
         <p:spPr>
           <a:xfrm>
             <a:off x="530280" y="2240280"/>
-            <a:ext cx="3958920" cy="877320"/>
+            <a:ext cx="3958560" cy="876960"/>
           </a:xfrm>
           <a:prstGeom prst="rect">
             <a:avLst/>
@@ -5483,7 +5699,7 @@
         <p:spPr>
           <a:xfrm>
             <a:off x="4727520" y="1783080"/>
-            <a:ext cx="4041360" cy="1425960"/>
+            <a:ext cx="4041000" cy="1425600"/>
           </a:xfrm>
           <a:prstGeom prst="rect">
             <a:avLst/>
@@ -5509,6 +5725,11 @@
             <a:noAutofit/>
           </a:bodyPr>
           <a:p>
+            <a:pPr>
+              <a:lnSpc>
+                <a:spcPct val="100000"/>
+              </a:lnSpc>
+            </a:pPr>
             <a:endParaRPr b="0" lang="en-US" sz="1800" spc="-1" strike="noStrike">
               <a:solidFill>
                 <a:srgbClr val="000000"/>
@@ -5527,7 +5748,7 @@
         <p:spPr>
           <a:xfrm>
             <a:off x="4727520" y="1783080"/>
-            <a:ext cx="45360" cy="1425960"/>
+            <a:ext cx="45000" cy="1425600"/>
           </a:xfrm>
           <a:prstGeom prst="rect">
             <a:avLst/>
@@ -5553,6 +5774,11 @@
             <a:noAutofit/>
           </a:bodyPr>
           <a:p>
+            <a:pPr>
+              <a:lnSpc>
+                <a:spcPct val="100000"/>
+              </a:lnSpc>
+            </a:pPr>
             <a:endParaRPr b="0" lang="en-US" sz="1800" spc="-1" strike="noStrike">
               <a:solidFill>
                 <a:srgbClr val="000000"/>
@@ -5571,7 +5797,7 @@
         <p:spPr>
           <a:xfrm>
             <a:off x="4855320" y="1901880"/>
-            <a:ext cx="3840120" cy="237240"/>
+            <a:ext cx="3839760" cy="236880"/>
           </a:xfrm>
           <a:prstGeom prst="rect">
             <a:avLst/>
@@ -5601,7 +5827,7 @@
               </a:tabLst>
             </a:pPr>
             <a:r>
-              <a:rPr b="1" lang="en-US" sz="850" spc="199" strike="noStrike">
+              <a:rPr b="1" lang="en-US" sz="850" spc="197" strike="noStrike">
                 <a:solidFill>
                   <a:srgbClr val="f28f16"/>
                 </a:solidFill>
@@ -5628,7 +5854,7 @@
         <p:spPr>
           <a:xfrm>
             <a:off x="4855320" y="2167200"/>
-            <a:ext cx="3785400" cy="16200"/>
+            <a:ext cx="3785040" cy="15840"/>
           </a:xfrm>
           <a:prstGeom prst="rect">
             <a:avLst/>
@@ -5654,6 +5880,11 @@
             <a:noAutofit/>
           </a:bodyPr>
           <a:p>
+            <a:pPr>
+              <a:lnSpc>
+                <a:spcPct val="100000"/>
+              </a:lnSpc>
+            </a:pPr>
             <a:endParaRPr b="0" lang="en-US" sz="1800" spc="-1" strike="noStrike">
               <a:solidFill>
                 <a:srgbClr val="000000"/>
@@ -5672,7 +5903,7 @@
         <p:spPr>
           <a:xfrm>
             <a:off x="4855320" y="2240280"/>
-            <a:ext cx="3840120" cy="877320"/>
+            <a:ext cx="3839760" cy="876960"/>
           </a:xfrm>
           <a:prstGeom prst="rect">
             <a:avLst/>
@@ -5827,7 +6058,7 @@
         <p:spPr>
           <a:xfrm>
             <a:off x="402480" y="3310200"/>
-            <a:ext cx="8366400" cy="1425960"/>
+            <a:ext cx="8366040" cy="1425600"/>
           </a:xfrm>
           <a:prstGeom prst="rect">
             <a:avLst/>
@@ -5853,6 +6084,11 @@
             <a:noAutofit/>
           </a:bodyPr>
           <a:p>
+            <a:pPr>
+              <a:lnSpc>
+                <a:spcPct val="100000"/>
+              </a:lnSpc>
+            </a:pPr>
             <a:endParaRPr b="0" lang="en-US" sz="1800" spc="-1" strike="noStrike">
               <a:solidFill>
                 <a:srgbClr val="000000"/>
@@ -5871,7 +6107,7 @@
         <p:spPr>
           <a:xfrm>
             <a:off x="402480" y="3310200"/>
-            <a:ext cx="45360" cy="1425960"/>
+            <a:ext cx="45000" cy="1425600"/>
           </a:xfrm>
           <a:prstGeom prst="rect">
             <a:avLst/>
@@ -5897,6 +6133,11 @@
             <a:noAutofit/>
           </a:bodyPr>
           <a:p>
+            <a:pPr>
+              <a:lnSpc>
+                <a:spcPct val="100000"/>
+              </a:lnSpc>
+            </a:pPr>
             <a:endParaRPr b="0" lang="en-US" sz="1800" spc="-1" strike="noStrike">
               <a:solidFill>
                 <a:srgbClr val="000000"/>
@@ -5915,7 +6156,7 @@
         <p:spPr>
           <a:xfrm>
             <a:off x="530280" y="3429000"/>
-            <a:ext cx="8165160" cy="237240"/>
+            <a:ext cx="8164800" cy="236880"/>
           </a:xfrm>
           <a:prstGeom prst="rect">
             <a:avLst/>
@@ -5945,7 +6186,7 @@
               </a:tabLst>
             </a:pPr>
             <a:r>
-              <a:rPr b="1" lang="en-US" sz="850" spc="199" strike="noStrike">
+              <a:rPr b="1" lang="en-US" sz="850" spc="197" strike="noStrike">
                 <a:solidFill>
                   <a:srgbClr val="f28f16"/>
                 </a:solidFill>
@@ -5972,7 +6213,7 @@
         <p:spPr>
           <a:xfrm>
             <a:off x="530280" y="3694320"/>
-            <a:ext cx="8110440" cy="16200"/>
+            <a:ext cx="8110080" cy="15840"/>
           </a:xfrm>
           <a:prstGeom prst="rect">
             <a:avLst/>
@@ -5998,6 +6239,11 @@
             <a:noAutofit/>
           </a:bodyPr>
           <a:p>
+            <a:pPr>
+              <a:lnSpc>
+                <a:spcPct val="100000"/>
+              </a:lnSpc>
+            </a:pPr>
             <a:endParaRPr b="0" lang="en-US" sz="1800" spc="-1" strike="noStrike">
               <a:solidFill>
                 <a:srgbClr val="000000"/>
@@ -6016,7 +6262,7 @@
         <p:spPr>
           <a:xfrm>
             <a:off x="530280" y="3767400"/>
-            <a:ext cx="8165160" cy="877320"/>
+            <a:ext cx="8164800" cy="876960"/>
           </a:xfrm>
           <a:prstGeom prst="rect">
             <a:avLst/>
@@ -6140,7 +6386,7 @@
         <p:spPr>
           <a:xfrm>
             <a:off x="0" y="4736520"/>
-            <a:ext cx="9143640" cy="406440"/>
+            <a:ext cx="9143280" cy="406080"/>
           </a:xfrm>
           <a:prstGeom prst="rect">
             <a:avLst/>
@@ -6166,6 +6412,11 @@
             <a:noAutofit/>
           </a:bodyPr>
           <a:p>
+            <a:pPr>
+              <a:lnSpc>
+                <a:spcPct val="100000"/>
+              </a:lnSpc>
+            </a:pPr>
             <a:endParaRPr b="0" lang="en-US" sz="1800" spc="-1" strike="noStrike">
               <a:solidFill>
                 <a:srgbClr val="ffffff"/>
@@ -6184,7 +6435,7 @@
         <p:spPr>
           <a:xfrm>
             <a:off x="420480" y="4736520"/>
-            <a:ext cx="8320680" cy="406440"/>
+            <a:ext cx="8320320" cy="406080"/>
           </a:xfrm>
           <a:prstGeom prst="rect">
             <a:avLst/>
@@ -6278,7 +6529,7 @@
         <p:spPr>
           <a:xfrm>
             <a:off x="0" y="0"/>
-            <a:ext cx="9143640" cy="1572480"/>
+            <a:ext cx="9143280" cy="1572120"/>
           </a:xfrm>
           <a:prstGeom prst="rect">
             <a:avLst/>
@@ -6304,6 +6555,11 @@
             <a:noAutofit/>
           </a:bodyPr>
           <a:p>
+            <a:pPr>
+              <a:lnSpc>
+                <a:spcPct val="100000"/>
+              </a:lnSpc>
+            </a:pPr>
             <a:endParaRPr b="0" lang="en-US" sz="1800" spc="-1" strike="noStrike">
               <a:solidFill>
                 <a:srgbClr val="ffffff"/>
@@ -6322,7 +6578,7 @@
         <p:spPr>
           <a:xfrm>
             <a:off x="0" y="1572840"/>
-            <a:ext cx="9143640" cy="50040"/>
+            <a:ext cx="9143280" cy="49680"/>
           </a:xfrm>
           <a:prstGeom prst="rect">
             <a:avLst/>
@@ -6348,6 +6604,11 @@
             <a:noAutofit/>
           </a:bodyPr>
           <a:p>
+            <a:pPr>
+              <a:lnSpc>
+                <a:spcPct val="100000"/>
+              </a:lnSpc>
+            </a:pPr>
             <a:endParaRPr b="0" lang="en-US" sz="1800" spc="-1" strike="noStrike">
               <a:solidFill>
                 <a:srgbClr val="000000"/>
@@ -6366,7 +6627,7 @@
         <p:spPr>
           <a:xfrm>
             <a:off x="438840" y="118800"/>
-            <a:ext cx="1371240" cy="255600"/>
+            <a:ext cx="1370880" cy="255240"/>
           </a:xfrm>
           <a:prstGeom prst="rect">
             <a:avLst/>
@@ -6396,7 +6657,7 @@
               </a:tabLst>
             </a:pPr>
             <a:r>
-              <a:rPr b="1" lang="en-US" sz="900" spc="398" strike="noStrike">
+              <a:rPr b="1" lang="en-US" sz="900" spc="395" strike="noStrike">
                 <a:solidFill>
                   <a:srgbClr val="f28f16"/>
                 </a:solidFill>
@@ -6423,7 +6684,7 @@
         <p:spPr>
           <a:xfrm>
             <a:off x="420480" y="329040"/>
-            <a:ext cx="8320680" cy="776880"/>
+            <a:ext cx="8320320" cy="776520"/>
           </a:xfrm>
           <a:prstGeom prst="rect">
             <a:avLst/>
@@ -6480,7 +6741,7 @@
         <p:spPr>
           <a:xfrm>
             <a:off x="438840" y="1134000"/>
-            <a:ext cx="8320680" cy="347040"/>
+            <a:ext cx="8320320" cy="346680"/>
           </a:xfrm>
           <a:prstGeom prst="rect">
             <a:avLst/>
@@ -6537,7 +6798,7 @@
         <p:spPr>
           <a:xfrm>
             <a:off x="402480" y="1783080"/>
-            <a:ext cx="2998800" cy="2944080"/>
+            <a:ext cx="2998440" cy="2943720"/>
           </a:xfrm>
           <a:prstGeom prst="rect">
             <a:avLst/>
@@ -6563,6 +6824,11 @@
             <a:noAutofit/>
           </a:bodyPr>
           <a:p>
+            <a:pPr>
+              <a:lnSpc>
+                <a:spcPct val="100000"/>
+              </a:lnSpc>
+            </a:pPr>
             <a:endParaRPr b="0" lang="en-US" sz="1800" spc="-1" strike="noStrike">
               <a:solidFill>
                 <a:srgbClr val="000000"/>
@@ -6581,7 +6847,7 @@
         <p:spPr>
           <a:xfrm>
             <a:off x="402480" y="1783080"/>
-            <a:ext cx="45360" cy="2944080"/>
+            <a:ext cx="45000" cy="2943720"/>
           </a:xfrm>
           <a:prstGeom prst="rect">
             <a:avLst/>
@@ -6607,6 +6873,11 @@
             <a:noAutofit/>
           </a:bodyPr>
           <a:p>
+            <a:pPr>
+              <a:lnSpc>
+                <a:spcPct val="100000"/>
+              </a:lnSpc>
+            </a:pPr>
             <a:endParaRPr b="0" lang="en-US" sz="1800" spc="-1" strike="noStrike">
               <a:solidFill>
                 <a:srgbClr val="000000"/>
@@ -6625,7 +6896,7 @@
         <p:spPr>
           <a:xfrm>
             <a:off x="530280" y="1901880"/>
-            <a:ext cx="2797560" cy="237240"/>
+            <a:ext cx="2797200" cy="236880"/>
           </a:xfrm>
           <a:prstGeom prst="rect">
             <a:avLst/>
@@ -6655,7 +6926,7 @@
               </a:tabLst>
             </a:pPr>
             <a:r>
-              <a:rPr b="1" lang="en-US" sz="850" spc="199" strike="noStrike">
+              <a:rPr b="1" lang="en-US" sz="850" spc="197" strike="noStrike">
                 <a:solidFill>
                   <a:srgbClr val="f28f16"/>
                 </a:solidFill>
@@ -6682,7 +6953,7 @@
         <p:spPr>
           <a:xfrm>
             <a:off x="530280" y="2167200"/>
-            <a:ext cx="2742840" cy="16200"/>
+            <a:ext cx="2742480" cy="15840"/>
           </a:xfrm>
           <a:prstGeom prst="rect">
             <a:avLst/>
@@ -6708,6 +6979,11 @@
             <a:noAutofit/>
           </a:bodyPr>
           <a:p>
+            <a:pPr>
+              <a:lnSpc>
+                <a:spcPct val="100000"/>
+              </a:lnSpc>
+            </a:pPr>
             <a:endParaRPr b="0" lang="en-US" sz="1800" spc="-1" strike="noStrike">
               <a:solidFill>
                 <a:srgbClr val="000000"/>
@@ -6726,7 +7002,7 @@
         <p:spPr>
           <a:xfrm>
             <a:off x="530280" y="2240280"/>
-            <a:ext cx="2797560" cy="2395440"/>
+            <a:ext cx="2797200" cy="2395080"/>
           </a:xfrm>
           <a:prstGeom prst="rect">
             <a:avLst/>
@@ -6912,7 +7188,7 @@
         <p:spPr>
           <a:xfrm>
             <a:off x="3547800" y="1783080"/>
-            <a:ext cx="2358720" cy="2944080"/>
+            <a:ext cx="2358360" cy="2943720"/>
           </a:xfrm>
           <a:prstGeom prst="rect">
             <a:avLst/>
@@ -6938,6 +7214,11 @@
             <a:noAutofit/>
           </a:bodyPr>
           <a:p>
+            <a:pPr>
+              <a:lnSpc>
+                <a:spcPct val="100000"/>
+              </a:lnSpc>
+            </a:pPr>
             <a:endParaRPr b="0" lang="en-US" sz="1800" spc="-1" strike="noStrike">
               <a:solidFill>
                 <a:srgbClr val="000000"/>
@@ -6956,7 +7237,7 @@
         <p:spPr>
           <a:xfrm>
             <a:off x="3547800" y="1783080"/>
-            <a:ext cx="45360" cy="2944080"/>
+            <a:ext cx="45000" cy="2943720"/>
           </a:xfrm>
           <a:prstGeom prst="rect">
             <a:avLst/>
@@ -6982,6 +7263,11 @@
             <a:noAutofit/>
           </a:bodyPr>
           <a:p>
+            <a:pPr>
+              <a:lnSpc>
+                <a:spcPct val="100000"/>
+              </a:lnSpc>
+            </a:pPr>
             <a:endParaRPr b="0" lang="en-US" sz="1800" spc="-1" strike="noStrike">
               <a:solidFill>
                 <a:srgbClr val="000000"/>
@@ -7000,7 +7286,7 @@
         <p:spPr>
           <a:xfrm>
             <a:off x="3675960" y="1901880"/>
-            <a:ext cx="2175840" cy="237240"/>
+            <a:ext cx="2175480" cy="236880"/>
           </a:xfrm>
           <a:prstGeom prst="rect">
             <a:avLst/>
@@ -7030,7 +7316,7 @@
               </a:tabLst>
             </a:pPr>
             <a:r>
-              <a:rPr b="1" lang="en-US" sz="850" spc="199" strike="noStrike">
+              <a:rPr b="1" lang="en-US" sz="850" spc="197" strike="noStrike">
                 <a:solidFill>
                   <a:srgbClr val="f28f16"/>
                 </a:solidFill>
@@ -7057,7 +7343,7 @@
         <p:spPr>
           <a:xfrm>
             <a:off x="3675960" y="2167200"/>
-            <a:ext cx="2048040" cy="16200"/>
+            <a:ext cx="2047680" cy="15840"/>
           </a:xfrm>
           <a:prstGeom prst="rect">
             <a:avLst/>
@@ -7083,6 +7369,11 @@
             <a:noAutofit/>
           </a:bodyPr>
           <a:p>
+            <a:pPr>
+              <a:lnSpc>
+                <a:spcPct val="100000"/>
+              </a:lnSpc>
+            </a:pPr>
             <a:endParaRPr b="0" lang="en-US" sz="1800" spc="-1" strike="noStrike">
               <a:solidFill>
                 <a:srgbClr val="000000"/>
@@ -7101,7 +7392,7 @@
         <p:spPr>
           <a:xfrm>
             <a:off x="3694320" y="2258640"/>
-            <a:ext cx="1462680" cy="310680"/>
+            <a:ext cx="1462320" cy="310320"/>
           </a:xfrm>
           <a:prstGeom prst="rect">
             <a:avLst/>
@@ -7158,7 +7449,7 @@
         <p:spPr>
           <a:xfrm>
             <a:off x="5285160" y="2258640"/>
-            <a:ext cx="529920" cy="310680"/>
+            <a:ext cx="529560" cy="310320"/>
           </a:xfrm>
           <a:prstGeom prst="rect">
             <a:avLst/>
@@ -7215,7 +7506,7 @@
         <p:spPr>
           <a:xfrm>
             <a:off x="3694320" y="2715840"/>
-            <a:ext cx="1462680" cy="310680"/>
+            <a:ext cx="1462320" cy="310320"/>
           </a:xfrm>
           <a:prstGeom prst="rect">
             <a:avLst/>
@@ -7272,7 +7563,7 @@
         <p:spPr>
           <a:xfrm>
             <a:off x="5285160" y="2715840"/>
-            <a:ext cx="529920" cy="310680"/>
+            <a:ext cx="529560" cy="310320"/>
           </a:xfrm>
           <a:prstGeom prst="rect">
             <a:avLst/>
@@ -7329,7 +7620,7 @@
         <p:spPr>
           <a:xfrm>
             <a:off x="3694320" y="3173040"/>
-            <a:ext cx="1462680" cy="310680"/>
+            <a:ext cx="1462320" cy="310320"/>
           </a:xfrm>
           <a:prstGeom prst="rect">
             <a:avLst/>
@@ -7386,7 +7677,7 @@
         <p:spPr>
           <a:xfrm>
             <a:off x="5285160" y="3173040"/>
-            <a:ext cx="529920" cy="310680"/>
+            <a:ext cx="529560" cy="310320"/>
           </a:xfrm>
           <a:prstGeom prst="rect">
             <a:avLst/>
@@ -7443,7 +7734,7 @@
         <p:spPr>
           <a:xfrm>
             <a:off x="3694320" y="3630240"/>
-            <a:ext cx="1462680" cy="310680"/>
+            <a:ext cx="1462320" cy="310320"/>
           </a:xfrm>
           <a:prstGeom prst="rect">
             <a:avLst/>
@@ -7500,7 +7791,7 @@
         <p:spPr>
           <a:xfrm>
             <a:off x="5285160" y="3630240"/>
-            <a:ext cx="529920" cy="310680"/>
+            <a:ext cx="529560" cy="310320"/>
           </a:xfrm>
           <a:prstGeom prst="rect">
             <a:avLst/>
@@ -7557,7 +7848,7 @@
         <p:spPr>
           <a:xfrm>
             <a:off x="3611880" y="4050720"/>
-            <a:ext cx="2230920" cy="420120"/>
+            <a:ext cx="2230560" cy="419760"/>
           </a:xfrm>
           <a:prstGeom prst="rect">
             <a:avLst/>
@@ -7583,6 +7874,11 @@
             <a:noAutofit/>
           </a:bodyPr>
           <a:p>
+            <a:pPr>
+              <a:lnSpc>
+                <a:spcPct val="100000"/>
+              </a:lnSpc>
+            </a:pPr>
             <a:endParaRPr b="0" lang="en-US" sz="1800" spc="-1" strike="noStrike">
               <a:solidFill>
                 <a:srgbClr val="ffffff"/>
@@ -7601,7 +7897,7 @@
         <p:spPr>
           <a:xfrm>
             <a:off x="3694320" y="4087440"/>
-            <a:ext cx="1462680" cy="310680"/>
+            <a:ext cx="1462320" cy="310320"/>
           </a:xfrm>
           <a:prstGeom prst="rect">
             <a:avLst/>
@@ -7658,7 +7954,7 @@
         <p:spPr>
           <a:xfrm>
             <a:off x="5285160" y="4087440"/>
-            <a:ext cx="529920" cy="310680"/>
+            <a:ext cx="529560" cy="310320"/>
           </a:xfrm>
           <a:prstGeom prst="rect">
             <a:avLst/>
@@ -7715,7 +8011,7 @@
         <p:spPr>
           <a:xfrm>
             <a:off x="6053400" y="1783080"/>
-            <a:ext cx="2715480" cy="2944080"/>
+            <a:ext cx="2715120" cy="2943720"/>
           </a:xfrm>
           <a:prstGeom prst="rect">
             <a:avLst/>
@@ -7741,6 +8037,11 @@
             <a:noAutofit/>
           </a:bodyPr>
           <a:p>
+            <a:pPr>
+              <a:lnSpc>
+                <a:spcPct val="100000"/>
+              </a:lnSpc>
+            </a:pPr>
             <a:endParaRPr b="0" lang="en-US" sz="1800" spc="-1" strike="noStrike">
               <a:solidFill>
                 <a:srgbClr val="000000"/>
@@ -7759,7 +8060,7 @@
         <p:spPr>
           <a:xfrm>
             <a:off x="6053400" y="1783080"/>
-            <a:ext cx="45360" cy="2944080"/>
+            <a:ext cx="45000" cy="2943720"/>
           </a:xfrm>
           <a:prstGeom prst="rect">
             <a:avLst/>
@@ -7785,6 +8086,11 @@
             <a:noAutofit/>
           </a:bodyPr>
           <a:p>
+            <a:pPr>
+              <a:lnSpc>
+                <a:spcPct val="100000"/>
+              </a:lnSpc>
+            </a:pPr>
             <a:endParaRPr b="0" lang="en-US" sz="1800" spc="-1" strike="noStrike">
               <a:solidFill>
                 <a:srgbClr val="000000"/>
@@ -7803,7 +8109,7 @@
         <p:spPr>
           <a:xfrm>
             <a:off x="6181200" y="1901880"/>
-            <a:ext cx="2514240" cy="237240"/>
+            <a:ext cx="2513880" cy="236880"/>
           </a:xfrm>
           <a:prstGeom prst="rect">
             <a:avLst/>
@@ -7833,7 +8139,7 @@
               </a:tabLst>
             </a:pPr>
             <a:r>
-              <a:rPr b="1" lang="en-US" sz="850" spc="199" strike="noStrike">
+              <a:rPr b="1" lang="en-US" sz="850" spc="197" strike="noStrike">
                 <a:solidFill>
                   <a:srgbClr val="f28f16"/>
                 </a:solidFill>
@@ -7860,7 +8166,7 @@
         <p:spPr>
           <a:xfrm>
             <a:off x="6181200" y="2167200"/>
-            <a:ext cx="2459520" cy="16200"/>
+            <a:ext cx="2459160" cy="15840"/>
           </a:xfrm>
           <a:prstGeom prst="rect">
             <a:avLst/>
@@ -7886,6 +8192,11 @@
             <a:noAutofit/>
           </a:bodyPr>
           <a:p>
+            <a:pPr>
+              <a:lnSpc>
+                <a:spcPct val="100000"/>
+              </a:lnSpc>
+            </a:pPr>
             <a:endParaRPr b="0" lang="en-US" sz="1800" spc="-1" strike="noStrike">
               <a:solidFill>
                 <a:srgbClr val="000000"/>
@@ -7904,7 +8215,7 @@
         <p:spPr>
           <a:xfrm>
             <a:off x="6181200" y="2240280"/>
-            <a:ext cx="2514240" cy="2395440"/>
+            <a:ext cx="2513880" cy="2395080"/>
           </a:xfrm>
           <a:prstGeom prst="rect">
             <a:avLst/>
@@ -8059,7 +8370,7 @@
         <p:spPr>
           <a:xfrm>
             <a:off x="0" y="4736520"/>
-            <a:ext cx="9143640" cy="406440"/>
+            <a:ext cx="9143280" cy="406080"/>
           </a:xfrm>
           <a:prstGeom prst="rect">
             <a:avLst/>
@@ -8085,6 +8396,11 @@
             <a:noAutofit/>
           </a:bodyPr>
           <a:p>
+            <a:pPr>
+              <a:lnSpc>
+                <a:spcPct val="100000"/>
+              </a:lnSpc>
+            </a:pPr>
             <a:endParaRPr b="0" lang="en-US" sz="1800" spc="-1" strike="noStrike">
               <a:solidFill>
                 <a:srgbClr val="ffffff"/>
@@ -8103,7 +8419,7 @@
         <p:spPr>
           <a:xfrm>
             <a:off x="420480" y="4736520"/>
-            <a:ext cx="8320680" cy="406440"/>
+            <a:ext cx="8320320" cy="406080"/>
           </a:xfrm>
           <a:prstGeom prst="rect">
             <a:avLst/>
@@ -8197,7 +8513,7 @@
         <p:spPr>
           <a:xfrm>
             <a:off x="0" y="0"/>
-            <a:ext cx="9143640" cy="1572480"/>
+            <a:ext cx="9143280" cy="1572120"/>
           </a:xfrm>
           <a:prstGeom prst="rect">
             <a:avLst/>
@@ -8223,6 +8539,11 @@
             <a:noAutofit/>
           </a:bodyPr>
           <a:p>
+            <a:pPr>
+              <a:lnSpc>
+                <a:spcPct val="100000"/>
+              </a:lnSpc>
+            </a:pPr>
             <a:endParaRPr b="0" lang="en-US" sz="1800" spc="-1" strike="noStrike">
               <a:solidFill>
                 <a:srgbClr val="ffffff"/>
@@ -8241,7 +8562,7 @@
         <p:spPr>
           <a:xfrm>
             <a:off x="0" y="1572840"/>
-            <a:ext cx="9143640" cy="50040"/>
+            <a:ext cx="9143280" cy="49680"/>
           </a:xfrm>
           <a:prstGeom prst="rect">
             <a:avLst/>
@@ -8267,6 +8588,11 @@
             <a:noAutofit/>
           </a:bodyPr>
           <a:p>
+            <a:pPr>
+              <a:lnSpc>
+                <a:spcPct val="100000"/>
+              </a:lnSpc>
+            </a:pPr>
             <a:endParaRPr b="0" lang="en-US" sz="1800" spc="-1" strike="noStrike">
               <a:solidFill>
                 <a:srgbClr val="000000"/>
@@ -8285,7 +8611,7 @@
         <p:spPr>
           <a:xfrm>
             <a:off x="438840" y="118800"/>
-            <a:ext cx="1371240" cy="255600"/>
+            <a:ext cx="1370880" cy="255240"/>
           </a:xfrm>
           <a:prstGeom prst="rect">
             <a:avLst/>
@@ -8315,7 +8641,7 @@
               </a:tabLst>
             </a:pPr>
             <a:r>
-              <a:rPr b="1" lang="en-US" sz="900" spc="398" strike="noStrike">
+              <a:rPr b="1" lang="en-US" sz="900" spc="395" strike="noStrike">
                 <a:solidFill>
                   <a:srgbClr val="f28f16"/>
                 </a:solidFill>
@@ -8342,7 +8668,7 @@
         <p:spPr>
           <a:xfrm>
             <a:off x="420480" y="329040"/>
-            <a:ext cx="8320680" cy="776880"/>
+            <a:ext cx="8320320" cy="776520"/>
           </a:xfrm>
           <a:prstGeom prst="rect">
             <a:avLst/>
@@ -8399,7 +8725,7 @@
         <p:spPr>
           <a:xfrm>
             <a:off x="438840" y="1134000"/>
-            <a:ext cx="8320680" cy="347040"/>
+            <a:ext cx="8320320" cy="346680"/>
           </a:xfrm>
           <a:prstGeom prst="rect">
             <a:avLst/>
@@ -8456,7 +8782,7 @@
         <p:spPr>
           <a:xfrm>
             <a:off x="402480" y="1783080"/>
-            <a:ext cx="2688120" cy="1444320"/>
+            <a:ext cx="2687760" cy="1443960"/>
           </a:xfrm>
           <a:prstGeom prst="rect">
             <a:avLst/>
@@ -8482,6 +8808,11 @@
             <a:noAutofit/>
           </a:bodyPr>
           <a:p>
+            <a:pPr>
+              <a:lnSpc>
+                <a:spcPct val="100000"/>
+              </a:lnSpc>
+            </a:pPr>
             <a:endParaRPr b="0" lang="en-US" sz="1800" spc="-1" strike="noStrike">
               <a:solidFill>
                 <a:srgbClr val="000000"/>
@@ -8500,7 +8831,7 @@
         <p:spPr>
           <a:xfrm>
             <a:off x="402480" y="1783080"/>
-            <a:ext cx="45360" cy="1444320"/>
+            <a:ext cx="45000" cy="1443960"/>
           </a:xfrm>
           <a:prstGeom prst="rect">
             <a:avLst/>
@@ -8526,6 +8857,11 @@
             <a:noAutofit/>
           </a:bodyPr>
           <a:p>
+            <a:pPr>
+              <a:lnSpc>
+                <a:spcPct val="100000"/>
+              </a:lnSpc>
+            </a:pPr>
             <a:endParaRPr b="0" lang="en-US" sz="1800" spc="-1" strike="noStrike">
               <a:solidFill>
                 <a:srgbClr val="000000"/>
@@ -8544,7 +8880,7 @@
         <p:spPr>
           <a:xfrm>
             <a:off x="530280" y="1901880"/>
-            <a:ext cx="2486880" cy="237240"/>
+            <a:ext cx="2486520" cy="236880"/>
           </a:xfrm>
           <a:prstGeom prst="rect">
             <a:avLst/>
@@ -8574,7 +8910,7 @@
               </a:tabLst>
             </a:pPr>
             <a:r>
-              <a:rPr b="1" lang="en-US" sz="850" spc="199" strike="noStrike">
+              <a:rPr b="1" lang="en-US" sz="850" spc="197" strike="noStrike">
                 <a:solidFill>
                   <a:srgbClr val="f28f16"/>
                 </a:solidFill>
@@ -8601,7 +8937,7 @@
         <p:spPr>
           <a:xfrm>
             <a:off x="530280" y="2167200"/>
-            <a:ext cx="2431800" cy="16200"/>
+            <a:ext cx="2431440" cy="15840"/>
           </a:xfrm>
           <a:prstGeom prst="rect">
             <a:avLst/>
@@ -8627,6 +8963,11 @@
             <a:noAutofit/>
           </a:bodyPr>
           <a:p>
+            <a:pPr>
+              <a:lnSpc>
+                <a:spcPct val="100000"/>
+              </a:lnSpc>
+            </a:pPr>
             <a:endParaRPr b="0" lang="en-US" sz="1800" spc="-1" strike="noStrike">
               <a:solidFill>
                 <a:srgbClr val="000000"/>
@@ -8645,7 +8986,7 @@
         <p:spPr>
           <a:xfrm>
             <a:off x="530280" y="2240280"/>
-            <a:ext cx="2486880" cy="895680"/>
+            <a:ext cx="2486520" cy="895320"/>
           </a:xfrm>
           <a:prstGeom prst="rect">
             <a:avLst/>
@@ -8769,7 +9110,7 @@
         <p:spPr>
           <a:xfrm>
             <a:off x="3191400" y="1783080"/>
-            <a:ext cx="2688120" cy="1444320"/>
+            <a:ext cx="2687760" cy="1443960"/>
           </a:xfrm>
           <a:prstGeom prst="rect">
             <a:avLst/>
@@ -8795,6 +9136,11 @@
             <a:noAutofit/>
           </a:bodyPr>
           <a:p>
+            <a:pPr>
+              <a:lnSpc>
+                <a:spcPct val="100000"/>
+              </a:lnSpc>
+            </a:pPr>
             <a:endParaRPr b="0" lang="en-US" sz="1800" spc="-1" strike="noStrike">
               <a:solidFill>
                 <a:srgbClr val="000000"/>
@@ -8813,7 +9159,7 @@
         <p:spPr>
           <a:xfrm>
             <a:off x="3191400" y="1783080"/>
-            <a:ext cx="45360" cy="1444320"/>
+            <a:ext cx="45000" cy="1443960"/>
           </a:xfrm>
           <a:prstGeom prst="rect">
             <a:avLst/>
@@ -8839,6 +9185,11 @@
             <a:noAutofit/>
           </a:bodyPr>
           <a:p>
+            <a:pPr>
+              <a:lnSpc>
+                <a:spcPct val="100000"/>
+              </a:lnSpc>
+            </a:pPr>
             <a:endParaRPr b="0" lang="en-US" sz="1800" spc="-1" strike="noStrike">
               <a:solidFill>
                 <a:srgbClr val="000000"/>
@@ -8857,7 +9208,7 @@
         <p:spPr>
           <a:xfrm>
             <a:off x="3319200" y="1901880"/>
-            <a:ext cx="2486880" cy="237240"/>
+            <a:ext cx="2486520" cy="236880"/>
           </a:xfrm>
           <a:prstGeom prst="rect">
             <a:avLst/>
@@ -8887,7 +9238,7 @@
               </a:tabLst>
             </a:pPr>
             <a:r>
-              <a:rPr b="1" lang="en-US" sz="850" spc="199" strike="noStrike">
+              <a:rPr b="1" lang="en-US" sz="850" spc="197" strike="noStrike">
                 <a:solidFill>
                   <a:srgbClr val="f28f16"/>
                 </a:solidFill>
@@ -8914,7 +9265,7 @@
         <p:spPr>
           <a:xfrm>
             <a:off x="3319200" y="2167200"/>
-            <a:ext cx="2431800" cy="16200"/>
+            <a:ext cx="2431440" cy="15840"/>
           </a:xfrm>
           <a:prstGeom prst="rect">
             <a:avLst/>
@@ -8940,6 +9291,11 @@
             <a:noAutofit/>
           </a:bodyPr>
           <a:p>
+            <a:pPr>
+              <a:lnSpc>
+                <a:spcPct val="100000"/>
+              </a:lnSpc>
+            </a:pPr>
             <a:endParaRPr b="0" lang="en-US" sz="1800" spc="-1" strike="noStrike">
               <a:solidFill>
                 <a:srgbClr val="000000"/>
@@ -8958,7 +9314,7 @@
         <p:spPr>
           <a:xfrm>
             <a:off x="3319200" y="2240280"/>
-            <a:ext cx="2486880" cy="895680"/>
+            <a:ext cx="2486520" cy="895320"/>
           </a:xfrm>
           <a:prstGeom prst="rect">
             <a:avLst/>
@@ -9082,7 +9438,7 @@
         <p:spPr>
           <a:xfrm>
             <a:off x="5961960" y="1783080"/>
-            <a:ext cx="2806920" cy="1444320"/>
+            <a:ext cx="2806560" cy="1443960"/>
           </a:xfrm>
           <a:prstGeom prst="rect">
             <a:avLst/>
@@ -9108,6 +9464,11 @@
             <a:noAutofit/>
           </a:bodyPr>
           <a:p>
+            <a:pPr>
+              <a:lnSpc>
+                <a:spcPct val="100000"/>
+              </a:lnSpc>
+            </a:pPr>
             <a:endParaRPr b="0" lang="en-US" sz="1800" spc="-1" strike="noStrike">
               <a:solidFill>
                 <a:srgbClr val="000000"/>
@@ -9126,7 +9487,7 @@
         <p:spPr>
           <a:xfrm>
             <a:off x="5961960" y="1783080"/>
-            <a:ext cx="45360" cy="1444320"/>
+            <a:ext cx="45000" cy="1443960"/>
           </a:xfrm>
           <a:prstGeom prst="rect">
             <a:avLst/>
@@ -9152,6 +9513,11 @@
             <a:noAutofit/>
           </a:bodyPr>
           <a:p>
+            <a:pPr>
+              <a:lnSpc>
+                <a:spcPct val="100000"/>
+              </a:lnSpc>
+            </a:pPr>
             <a:endParaRPr b="0" lang="en-US" sz="1800" spc="-1" strike="noStrike">
               <a:solidFill>
                 <a:srgbClr val="000000"/>
@@ -9170,7 +9536,7 @@
         <p:spPr>
           <a:xfrm>
             <a:off x="6089760" y="1901880"/>
-            <a:ext cx="2605680" cy="237240"/>
+            <a:ext cx="2605320" cy="236880"/>
           </a:xfrm>
           <a:prstGeom prst="rect">
             <a:avLst/>
@@ -9200,7 +9566,7 @@
               </a:tabLst>
             </a:pPr>
             <a:r>
-              <a:rPr b="1" lang="en-US" sz="850" spc="199" strike="noStrike">
+              <a:rPr b="1" lang="en-US" sz="850" spc="197" strike="noStrike">
                 <a:solidFill>
                   <a:srgbClr val="f28f16"/>
                 </a:solidFill>
@@ -9227,7 +9593,7 @@
         <p:spPr>
           <a:xfrm>
             <a:off x="6089760" y="2167200"/>
-            <a:ext cx="2550960" cy="16200"/>
+            <a:ext cx="2550600" cy="15840"/>
           </a:xfrm>
           <a:prstGeom prst="rect">
             <a:avLst/>
@@ -9253,6 +9619,11 @@
             <a:noAutofit/>
           </a:bodyPr>
           <a:p>
+            <a:pPr>
+              <a:lnSpc>
+                <a:spcPct val="100000"/>
+              </a:lnSpc>
+            </a:pPr>
             <a:endParaRPr b="0" lang="en-US" sz="1800" spc="-1" strike="noStrike">
               <a:solidFill>
                 <a:srgbClr val="000000"/>
@@ -9271,7 +9642,7 @@
         <p:spPr>
           <a:xfrm>
             <a:off x="6089760" y="2240280"/>
-            <a:ext cx="2605680" cy="895680"/>
+            <a:ext cx="2605320" cy="895320"/>
           </a:xfrm>
           <a:prstGeom prst="rect">
             <a:avLst/>
@@ -9395,7 +9766,7 @@
         <p:spPr>
           <a:xfrm>
             <a:off x="402480" y="3337560"/>
-            <a:ext cx="2688120" cy="1407960"/>
+            <a:ext cx="2687760" cy="1407600"/>
           </a:xfrm>
           <a:prstGeom prst="rect">
             <a:avLst/>
@@ -9421,6 +9792,11 @@
             <a:noAutofit/>
           </a:bodyPr>
           <a:p>
+            <a:pPr>
+              <a:lnSpc>
+                <a:spcPct val="100000"/>
+              </a:lnSpc>
+            </a:pPr>
             <a:endParaRPr b="0" lang="en-US" sz="1800" spc="-1" strike="noStrike">
               <a:solidFill>
                 <a:srgbClr val="000000"/>
@@ -9439,7 +9815,7 @@
         <p:spPr>
           <a:xfrm>
             <a:off x="402480" y="3337560"/>
-            <a:ext cx="45360" cy="1407960"/>
+            <a:ext cx="45000" cy="1407600"/>
           </a:xfrm>
           <a:prstGeom prst="rect">
             <a:avLst/>
@@ -9465,6 +9841,11 @@
             <a:noAutofit/>
           </a:bodyPr>
           <a:p>
+            <a:pPr>
+              <a:lnSpc>
+                <a:spcPct val="100000"/>
+              </a:lnSpc>
+            </a:pPr>
             <a:endParaRPr b="0" lang="en-US" sz="1800" spc="-1" strike="noStrike">
               <a:solidFill>
                 <a:srgbClr val="000000"/>
@@ -9483,7 +9864,7 @@
         <p:spPr>
           <a:xfrm>
             <a:off x="530280" y="3456360"/>
-            <a:ext cx="2486880" cy="237240"/>
+            <a:ext cx="2486520" cy="236880"/>
           </a:xfrm>
           <a:prstGeom prst="rect">
             <a:avLst/>
@@ -9513,7 +9894,7 @@
               </a:tabLst>
             </a:pPr>
             <a:r>
-              <a:rPr b="1" lang="en-US" sz="850" spc="199" strike="noStrike">
+              <a:rPr b="1" lang="en-US" sz="850" spc="197" strike="noStrike">
                 <a:solidFill>
                   <a:srgbClr val="f28f16"/>
                 </a:solidFill>
@@ -9540,7 +9921,7 @@
         <p:spPr>
           <a:xfrm>
             <a:off x="530280" y="3721680"/>
-            <a:ext cx="2431800" cy="16200"/>
+            <a:ext cx="2431440" cy="15840"/>
           </a:xfrm>
           <a:prstGeom prst="rect">
             <a:avLst/>
@@ -9566,6 +9947,11 @@
             <a:noAutofit/>
           </a:bodyPr>
           <a:p>
+            <a:pPr>
+              <a:lnSpc>
+                <a:spcPct val="100000"/>
+              </a:lnSpc>
+            </a:pPr>
             <a:endParaRPr b="0" lang="en-US" sz="1800" spc="-1" strike="noStrike">
               <a:solidFill>
                 <a:srgbClr val="000000"/>
@@ -9584,7 +9970,7 @@
         <p:spPr>
           <a:xfrm>
             <a:off x="530280" y="3794760"/>
-            <a:ext cx="2486880" cy="859320"/>
+            <a:ext cx="2486520" cy="858960"/>
           </a:xfrm>
           <a:prstGeom prst="rect">
             <a:avLst/>
@@ -9708,7 +10094,7 @@
         <p:spPr>
           <a:xfrm>
             <a:off x="3232440" y="3337560"/>
-            <a:ext cx="2688120" cy="1407960"/>
+            <a:ext cx="2687760" cy="1407600"/>
           </a:xfrm>
           <a:prstGeom prst="rect">
             <a:avLst/>
@@ -9734,6 +10120,11 @@
             <a:noAutofit/>
           </a:bodyPr>
           <a:p>
+            <a:pPr>
+              <a:lnSpc>
+                <a:spcPct val="100000"/>
+              </a:lnSpc>
+            </a:pPr>
             <a:endParaRPr b="0" lang="en-US" sz="1800" spc="-1" strike="noStrike">
               <a:solidFill>
                 <a:srgbClr val="000000"/>
@@ -9752,7 +10143,7 @@
         <p:spPr>
           <a:xfrm>
             <a:off x="3232440" y="3337560"/>
-            <a:ext cx="45360" cy="1407960"/>
+            <a:ext cx="45000" cy="1407600"/>
           </a:xfrm>
           <a:prstGeom prst="rect">
             <a:avLst/>
@@ -9778,6 +10169,11 @@
             <a:noAutofit/>
           </a:bodyPr>
           <a:p>
+            <a:pPr>
+              <a:lnSpc>
+                <a:spcPct val="100000"/>
+              </a:lnSpc>
+            </a:pPr>
             <a:endParaRPr b="0" lang="en-US" sz="1800" spc="-1" strike="noStrike">
               <a:solidFill>
                 <a:srgbClr val="000000"/>
@@ -9796,7 +10192,7 @@
         <p:spPr>
           <a:xfrm>
             <a:off x="3360600" y="3456360"/>
-            <a:ext cx="2486880" cy="237240"/>
+            <a:ext cx="2486520" cy="236880"/>
           </a:xfrm>
           <a:prstGeom prst="rect">
             <a:avLst/>
@@ -9826,7 +10222,7 @@
               </a:tabLst>
             </a:pPr>
             <a:r>
-              <a:rPr b="1" lang="en-US" sz="850" spc="199" strike="noStrike">
+              <a:rPr b="1" lang="en-US" sz="850" spc="197" strike="noStrike">
                 <a:solidFill>
                   <a:srgbClr val="f28f16"/>
                 </a:solidFill>
@@ -9853,7 +10249,7 @@
         <p:spPr>
           <a:xfrm>
             <a:off x="3360600" y="3721680"/>
-            <a:ext cx="2431800" cy="16200"/>
+            <a:ext cx="2431440" cy="15840"/>
           </a:xfrm>
           <a:prstGeom prst="rect">
             <a:avLst/>
@@ -9879,6 +10275,11 @@
             <a:noAutofit/>
           </a:bodyPr>
           <a:p>
+            <a:pPr>
+              <a:lnSpc>
+                <a:spcPct val="100000"/>
+              </a:lnSpc>
+            </a:pPr>
             <a:endParaRPr b="0" lang="en-US" sz="1800" spc="-1" strike="noStrike">
               <a:solidFill>
                 <a:srgbClr val="000000"/>
@@ -9897,7 +10298,7 @@
         <p:spPr>
           <a:xfrm>
             <a:off x="3360600" y="3794760"/>
-            <a:ext cx="2486880" cy="859320"/>
+            <a:ext cx="2486520" cy="858960"/>
           </a:xfrm>
           <a:prstGeom prst="rect">
             <a:avLst/>
@@ -10021,7 +10422,7 @@
         <p:spPr>
           <a:xfrm>
             <a:off x="6062400" y="3337560"/>
-            <a:ext cx="2688120" cy="1407960"/>
+            <a:ext cx="2687760" cy="1407600"/>
           </a:xfrm>
           <a:prstGeom prst="rect">
             <a:avLst/>
@@ -10047,6 +10448,11 @@
             <a:noAutofit/>
           </a:bodyPr>
           <a:p>
+            <a:pPr>
+              <a:lnSpc>
+                <a:spcPct val="100000"/>
+              </a:lnSpc>
+            </a:pPr>
             <a:endParaRPr b="0" lang="en-US" sz="1800" spc="-1" strike="noStrike">
               <a:solidFill>
                 <a:srgbClr val="000000"/>
@@ -10065,7 +10471,7 @@
         <p:spPr>
           <a:xfrm>
             <a:off x="6062400" y="3337560"/>
-            <a:ext cx="45360" cy="1407960"/>
+            <a:ext cx="45000" cy="1407600"/>
           </a:xfrm>
           <a:prstGeom prst="rect">
             <a:avLst/>
@@ -10091,6 +10497,11 @@
             <a:noAutofit/>
           </a:bodyPr>
           <a:p>
+            <a:pPr>
+              <a:lnSpc>
+                <a:spcPct val="100000"/>
+              </a:lnSpc>
+            </a:pPr>
             <a:endParaRPr b="0" lang="en-US" sz="1800" spc="-1" strike="noStrike">
               <a:solidFill>
                 <a:srgbClr val="000000"/>
@@ -10109,7 +10520,7 @@
         <p:spPr>
           <a:xfrm>
             <a:off x="6190560" y="3456360"/>
-            <a:ext cx="2486880" cy="237240"/>
+            <a:ext cx="2486520" cy="236880"/>
           </a:xfrm>
           <a:prstGeom prst="rect">
             <a:avLst/>
@@ -10139,7 +10550,7 @@
               </a:tabLst>
             </a:pPr>
             <a:r>
-              <a:rPr b="1" lang="en-US" sz="850" spc="199" strike="noStrike">
+              <a:rPr b="1" lang="en-US" sz="850" spc="197" strike="noStrike">
                 <a:solidFill>
                   <a:srgbClr val="f28f16"/>
                 </a:solidFill>
@@ -10166,7 +10577,7 @@
         <p:spPr>
           <a:xfrm>
             <a:off x="6190560" y="3721680"/>
-            <a:ext cx="2431800" cy="16200"/>
+            <a:ext cx="2431440" cy="15840"/>
           </a:xfrm>
           <a:prstGeom prst="rect">
             <a:avLst/>
@@ -10192,6 +10603,11 @@
             <a:noAutofit/>
           </a:bodyPr>
           <a:p>
+            <a:pPr>
+              <a:lnSpc>
+                <a:spcPct val="100000"/>
+              </a:lnSpc>
+            </a:pPr>
             <a:endParaRPr b="0" lang="en-US" sz="1800" spc="-1" strike="noStrike">
               <a:solidFill>
                 <a:srgbClr val="000000"/>
@@ -10210,7 +10626,7 @@
         <p:spPr>
           <a:xfrm>
             <a:off x="6190560" y="3794760"/>
-            <a:ext cx="2486880" cy="859320"/>
+            <a:ext cx="2486520" cy="858960"/>
           </a:xfrm>
           <a:prstGeom prst="rect">
             <a:avLst/>
@@ -10371,7 +10787,7 @@
         <p:spPr>
           <a:xfrm>
             <a:off x="0" y="0"/>
-            <a:ext cx="9143640" cy="1572480"/>
+            <a:ext cx="9143280" cy="1572120"/>
           </a:xfrm>
           <a:prstGeom prst="rect">
             <a:avLst/>
@@ -10397,6 +10813,11 @@
             <a:noAutofit/>
           </a:bodyPr>
           <a:p>
+            <a:pPr>
+              <a:lnSpc>
+                <a:spcPct val="100000"/>
+              </a:lnSpc>
+            </a:pPr>
             <a:endParaRPr b="0" lang="en-US" sz="1800" spc="-1" strike="noStrike">
               <a:solidFill>
                 <a:srgbClr val="ffffff"/>
@@ -10415,7 +10836,7 @@
         <p:spPr>
           <a:xfrm>
             <a:off x="0" y="1572840"/>
-            <a:ext cx="9143640" cy="50040"/>
+            <a:ext cx="9143280" cy="49680"/>
           </a:xfrm>
           <a:prstGeom prst="rect">
             <a:avLst/>
@@ -10441,6 +10862,11 @@
             <a:noAutofit/>
           </a:bodyPr>
           <a:p>
+            <a:pPr>
+              <a:lnSpc>
+                <a:spcPct val="100000"/>
+              </a:lnSpc>
+            </a:pPr>
             <a:endParaRPr b="0" lang="en-US" sz="1800" spc="-1" strike="noStrike">
               <a:solidFill>
                 <a:srgbClr val="000000"/>
@@ -10459,7 +10885,7 @@
         <p:spPr>
           <a:xfrm>
             <a:off x="438840" y="118800"/>
-            <a:ext cx="1371240" cy="255600"/>
+            <a:ext cx="1370880" cy="255240"/>
           </a:xfrm>
           <a:prstGeom prst="rect">
             <a:avLst/>
@@ -10489,7 +10915,7 @@
               </a:tabLst>
             </a:pPr>
             <a:r>
-              <a:rPr b="1" lang="en-US" sz="900" spc="398" strike="noStrike">
+              <a:rPr b="1" lang="en-US" sz="900" spc="395" strike="noStrike">
                 <a:solidFill>
                   <a:srgbClr val="f28f16"/>
                 </a:solidFill>
@@ -10516,7 +10942,7 @@
         <p:spPr>
           <a:xfrm>
             <a:off x="420480" y="329040"/>
-            <a:ext cx="8320680" cy="776880"/>
+            <a:ext cx="8320320" cy="776520"/>
           </a:xfrm>
           <a:prstGeom prst="rect">
             <a:avLst/>
@@ -10573,7 +10999,7 @@
         <p:spPr>
           <a:xfrm>
             <a:off x="438840" y="1134000"/>
-            <a:ext cx="8320680" cy="347040"/>
+            <a:ext cx="8320320" cy="346680"/>
           </a:xfrm>
           <a:prstGeom prst="rect">
             <a:avLst/>
@@ -10630,7 +11056,7 @@
         <p:spPr>
           <a:xfrm>
             <a:off x="402480" y="1783080"/>
-            <a:ext cx="4160160" cy="1425960"/>
+            <a:ext cx="4159800" cy="1425600"/>
           </a:xfrm>
           <a:prstGeom prst="rect">
             <a:avLst/>
@@ -10656,6 +11082,11 @@
             <a:noAutofit/>
           </a:bodyPr>
           <a:p>
+            <a:pPr>
+              <a:lnSpc>
+                <a:spcPct val="100000"/>
+              </a:lnSpc>
+            </a:pPr>
             <a:endParaRPr b="0" lang="en-US" sz="1800" spc="-1" strike="noStrike">
               <a:solidFill>
                 <a:srgbClr val="000000"/>
@@ -10674,7 +11105,7 @@
         <p:spPr>
           <a:xfrm>
             <a:off x="402480" y="1783080"/>
-            <a:ext cx="45360" cy="1425960"/>
+            <a:ext cx="45000" cy="1425600"/>
           </a:xfrm>
           <a:prstGeom prst="rect">
             <a:avLst/>
@@ -10700,6 +11131,11 @@
             <a:noAutofit/>
           </a:bodyPr>
           <a:p>
+            <a:pPr>
+              <a:lnSpc>
+                <a:spcPct val="100000"/>
+              </a:lnSpc>
+            </a:pPr>
             <a:endParaRPr b="0" lang="en-US" sz="1800" spc="-1" strike="noStrike">
               <a:solidFill>
                 <a:srgbClr val="000000"/>
@@ -10718,7 +11154,7 @@
         <p:spPr>
           <a:xfrm>
             <a:off x="530280" y="1901880"/>
-            <a:ext cx="3958920" cy="237240"/>
+            <a:ext cx="3958560" cy="236880"/>
           </a:xfrm>
           <a:prstGeom prst="rect">
             <a:avLst/>
@@ -10748,7 +11184,7 @@
               </a:tabLst>
             </a:pPr>
             <a:r>
-              <a:rPr b="1" lang="en-US" sz="850" spc="199" strike="noStrike">
+              <a:rPr b="1" lang="en-US" sz="850" spc="197" strike="noStrike">
                 <a:solidFill>
                   <a:srgbClr val="f28f16"/>
                 </a:solidFill>
@@ -10775,7 +11211,7 @@
         <p:spPr>
           <a:xfrm>
             <a:off x="530280" y="2167200"/>
-            <a:ext cx="3904200" cy="16200"/>
+            <a:ext cx="3903840" cy="15840"/>
           </a:xfrm>
           <a:prstGeom prst="rect">
             <a:avLst/>
@@ -10801,6 +11237,11 @@
             <a:noAutofit/>
           </a:bodyPr>
           <a:p>
+            <a:pPr>
+              <a:lnSpc>
+                <a:spcPct val="100000"/>
+              </a:lnSpc>
+            </a:pPr>
             <a:endParaRPr b="0" lang="en-US" sz="1800" spc="-1" strike="noStrike">
               <a:solidFill>
                 <a:srgbClr val="000000"/>
@@ -10819,7 +11260,7 @@
         <p:spPr>
           <a:xfrm>
             <a:off x="530280" y="2240280"/>
-            <a:ext cx="3958920" cy="877320"/>
+            <a:ext cx="3958560" cy="876960"/>
           </a:xfrm>
           <a:prstGeom prst="rect">
             <a:avLst/>
@@ -10974,7 +11415,7 @@
         <p:spPr>
           <a:xfrm>
             <a:off x="4727520" y="1783080"/>
-            <a:ext cx="4041360" cy="1425960"/>
+            <a:ext cx="4041000" cy="1425600"/>
           </a:xfrm>
           <a:prstGeom prst="rect">
             <a:avLst/>
@@ -11000,6 +11441,11 @@
             <a:noAutofit/>
           </a:bodyPr>
           <a:p>
+            <a:pPr>
+              <a:lnSpc>
+                <a:spcPct val="100000"/>
+              </a:lnSpc>
+            </a:pPr>
             <a:endParaRPr b="0" lang="en-US" sz="1800" spc="-1" strike="noStrike">
               <a:solidFill>
                 <a:srgbClr val="000000"/>
@@ -11018,7 +11464,7 @@
         <p:spPr>
           <a:xfrm>
             <a:off x="4727520" y="1783080"/>
-            <a:ext cx="45360" cy="1425960"/>
+            <a:ext cx="45000" cy="1425600"/>
           </a:xfrm>
           <a:prstGeom prst="rect">
             <a:avLst/>
@@ -11044,6 +11490,11 @@
             <a:noAutofit/>
           </a:bodyPr>
           <a:p>
+            <a:pPr>
+              <a:lnSpc>
+                <a:spcPct val="100000"/>
+              </a:lnSpc>
+            </a:pPr>
             <a:endParaRPr b="0" lang="en-US" sz="1800" spc="-1" strike="noStrike">
               <a:solidFill>
                 <a:srgbClr val="000000"/>
@@ -11062,7 +11513,7 @@
         <p:spPr>
           <a:xfrm>
             <a:off x="4855320" y="1901880"/>
-            <a:ext cx="3840120" cy="237240"/>
+            <a:ext cx="3839760" cy="236880"/>
           </a:xfrm>
           <a:prstGeom prst="rect">
             <a:avLst/>
@@ -11092,7 +11543,7 @@
               </a:tabLst>
             </a:pPr>
             <a:r>
-              <a:rPr b="1" lang="en-US" sz="850" spc="199" strike="noStrike">
+              <a:rPr b="1" lang="en-US" sz="850" spc="197" strike="noStrike">
                 <a:solidFill>
                   <a:srgbClr val="f28f16"/>
                 </a:solidFill>
@@ -11119,7 +11570,7 @@
         <p:spPr>
           <a:xfrm>
             <a:off x="4855320" y="2167200"/>
-            <a:ext cx="3785400" cy="16200"/>
+            <a:ext cx="3785040" cy="15840"/>
           </a:xfrm>
           <a:prstGeom prst="rect">
             <a:avLst/>
@@ -11145,6 +11596,11 @@
             <a:noAutofit/>
           </a:bodyPr>
           <a:p>
+            <a:pPr>
+              <a:lnSpc>
+                <a:spcPct val="100000"/>
+              </a:lnSpc>
+            </a:pPr>
             <a:endParaRPr b="0" lang="en-US" sz="1800" spc="-1" strike="noStrike">
               <a:solidFill>
                 <a:srgbClr val="000000"/>
@@ -11163,7 +11619,7 @@
         <p:spPr>
           <a:xfrm>
             <a:off x="4855320" y="2240280"/>
-            <a:ext cx="3840120" cy="877320"/>
+            <a:ext cx="3839760" cy="876960"/>
           </a:xfrm>
           <a:prstGeom prst="rect">
             <a:avLst/>
@@ -11318,7 +11774,7 @@
         <p:spPr>
           <a:xfrm>
             <a:off x="402480" y="3319200"/>
-            <a:ext cx="8366400" cy="255600"/>
+            <a:ext cx="8366040" cy="255240"/>
           </a:xfrm>
           <a:prstGeom prst="rect">
             <a:avLst/>
@@ -11348,7 +11804,7 @@
               </a:tabLst>
             </a:pPr>
             <a:r>
-              <a:rPr b="1" lang="en-US" sz="850" spc="199" strike="noStrike">
+              <a:rPr b="1" lang="en-US" sz="850" spc="197" strike="noStrike">
                 <a:solidFill>
                   <a:srgbClr val="f28f16"/>
                 </a:solidFill>
@@ -11375,7 +11831,7 @@
         <p:spPr>
           <a:xfrm>
             <a:off x="402480" y="3593520"/>
-            <a:ext cx="8366400" cy="19800"/>
+            <a:ext cx="8366040" cy="19440"/>
           </a:xfrm>
           <a:prstGeom prst="rect">
             <a:avLst/>
@@ -11401,6 +11857,11 @@
             <a:noAutofit/>
           </a:bodyPr>
           <a:p>
+            <a:pPr>
+              <a:lnSpc>
+                <a:spcPct val="100000"/>
+              </a:lnSpc>
+            </a:pPr>
             <a:endParaRPr b="0" lang="en-US" sz="1800" spc="-1" strike="noStrike">
               <a:solidFill>
                 <a:srgbClr val="000000"/>
@@ -11419,7 +11880,7 @@
         <p:spPr>
           <a:xfrm>
             <a:off x="402480" y="3630240"/>
-            <a:ext cx="1572480" cy="1078560"/>
+            <a:ext cx="1572120" cy="1078200"/>
           </a:xfrm>
           <a:prstGeom prst="rect">
             <a:avLst/>
@@ -11445,6 +11906,11 @@
             <a:noAutofit/>
           </a:bodyPr>
           <a:p>
+            <a:pPr>
+              <a:lnSpc>
+                <a:spcPct val="100000"/>
+              </a:lnSpc>
+            </a:pPr>
             <a:endParaRPr b="0" lang="en-US" sz="1800" spc="-1" strike="noStrike">
               <a:solidFill>
                 <a:srgbClr val="000000"/>
@@ -11463,7 +11929,7 @@
         <p:spPr>
           <a:xfrm>
             <a:off x="402480" y="3630240"/>
-            <a:ext cx="1572480" cy="45360"/>
+            <a:ext cx="1572120" cy="45000"/>
           </a:xfrm>
           <a:prstGeom prst="rect">
             <a:avLst/>
@@ -11489,6 +11955,11 @@
             <a:noAutofit/>
           </a:bodyPr>
           <a:p>
+            <a:pPr>
+              <a:lnSpc>
+                <a:spcPct val="100000"/>
+              </a:lnSpc>
+            </a:pPr>
             <a:endParaRPr b="0" lang="en-US" sz="1800" spc="-1" strike="noStrike">
               <a:solidFill>
                 <a:srgbClr val="000000"/>
@@ -11507,7 +11978,7 @@
         <p:spPr>
           <a:xfrm>
             <a:off x="511920" y="3721680"/>
-            <a:ext cx="273960" cy="273960"/>
+            <a:ext cx="273600" cy="273600"/>
           </a:xfrm>
           <a:prstGeom prst="rect">
             <a:avLst/>
@@ -11564,7 +12035,7 @@
         <p:spPr>
           <a:xfrm>
             <a:off x="511920" y="4014360"/>
-            <a:ext cx="1389600" cy="310680"/>
+            <a:ext cx="1389240" cy="310320"/>
           </a:xfrm>
           <a:prstGeom prst="rect">
             <a:avLst/>
@@ -11621,7 +12092,7 @@
         <p:spPr>
           <a:xfrm>
             <a:off x="511920" y="4325040"/>
-            <a:ext cx="1389600" cy="347040"/>
+            <a:ext cx="1389240" cy="346680"/>
           </a:xfrm>
           <a:prstGeom prst="rect">
             <a:avLst/>
@@ -11704,7 +12175,7 @@
         <p:spPr>
           <a:xfrm>
             <a:off x="2080440" y="3630240"/>
-            <a:ext cx="1572480" cy="1078560"/>
+            <a:ext cx="1572120" cy="1078200"/>
           </a:xfrm>
           <a:prstGeom prst="rect">
             <a:avLst/>
@@ -11730,6 +12201,11 @@
             <a:noAutofit/>
           </a:bodyPr>
           <a:p>
+            <a:pPr>
+              <a:lnSpc>
+                <a:spcPct val="100000"/>
+              </a:lnSpc>
+            </a:pPr>
             <a:endParaRPr b="0" lang="en-US" sz="1800" spc="-1" strike="noStrike">
               <a:solidFill>
                 <a:srgbClr val="000000"/>
@@ -11748,7 +12224,7 @@
         <p:spPr>
           <a:xfrm>
             <a:off x="2080440" y="3630240"/>
-            <a:ext cx="1572480" cy="45360"/>
+            <a:ext cx="1572120" cy="45000"/>
           </a:xfrm>
           <a:prstGeom prst="rect">
             <a:avLst/>
@@ -11774,6 +12250,11 @@
             <a:noAutofit/>
           </a:bodyPr>
           <a:p>
+            <a:pPr>
+              <a:lnSpc>
+                <a:spcPct val="100000"/>
+              </a:lnSpc>
+            </a:pPr>
             <a:endParaRPr b="0" lang="en-US" sz="1800" spc="-1" strike="noStrike">
               <a:solidFill>
                 <a:srgbClr val="000000"/>
@@ -11792,7 +12273,7 @@
         <p:spPr>
           <a:xfrm>
             <a:off x="2189880" y="3721680"/>
-            <a:ext cx="273960" cy="273960"/>
+            <a:ext cx="273600" cy="273600"/>
           </a:xfrm>
           <a:prstGeom prst="rect">
             <a:avLst/>
@@ -11849,7 +12330,7 @@
         <p:spPr>
           <a:xfrm>
             <a:off x="2189880" y="4014360"/>
-            <a:ext cx="1389600" cy="310680"/>
+            <a:ext cx="1389240" cy="310320"/>
           </a:xfrm>
           <a:prstGeom prst="rect">
             <a:avLst/>
@@ -11906,7 +12387,7 @@
         <p:spPr>
           <a:xfrm>
             <a:off x="2189880" y="4325040"/>
-            <a:ext cx="1389600" cy="347040"/>
+            <a:ext cx="1389240" cy="346680"/>
           </a:xfrm>
           <a:prstGeom prst="rect">
             <a:avLst/>
@@ -11989,7 +12470,7 @@
         <p:spPr>
           <a:xfrm>
             <a:off x="3758040" y="3630240"/>
-            <a:ext cx="1572480" cy="1078560"/>
+            <a:ext cx="1572120" cy="1078200"/>
           </a:xfrm>
           <a:prstGeom prst="rect">
             <a:avLst/>
@@ -12015,6 +12496,11 @@
             <a:noAutofit/>
           </a:bodyPr>
           <a:p>
+            <a:pPr>
+              <a:lnSpc>
+                <a:spcPct val="100000"/>
+              </a:lnSpc>
+            </a:pPr>
             <a:endParaRPr b="0" lang="en-US" sz="1800" spc="-1" strike="noStrike">
               <a:solidFill>
                 <a:srgbClr val="000000"/>
@@ -12033,7 +12519,7 @@
         <p:spPr>
           <a:xfrm>
             <a:off x="3758040" y="3630240"/>
-            <a:ext cx="1572480" cy="45360"/>
+            <a:ext cx="1572120" cy="45000"/>
           </a:xfrm>
           <a:prstGeom prst="rect">
             <a:avLst/>
@@ -12059,6 +12545,11 @@
             <a:noAutofit/>
           </a:bodyPr>
           <a:p>
+            <a:pPr>
+              <a:lnSpc>
+                <a:spcPct val="100000"/>
+              </a:lnSpc>
+            </a:pPr>
             <a:endParaRPr b="0" lang="en-US" sz="1800" spc="-1" strike="noStrike">
               <a:solidFill>
                 <a:srgbClr val="000000"/>
@@ -12077,7 +12568,7 @@
         <p:spPr>
           <a:xfrm>
             <a:off x="3867840" y="3721680"/>
-            <a:ext cx="273960" cy="273960"/>
+            <a:ext cx="273600" cy="273600"/>
           </a:xfrm>
           <a:prstGeom prst="rect">
             <a:avLst/>
@@ -12134,7 +12625,7 @@
         <p:spPr>
           <a:xfrm>
             <a:off x="3867840" y="4014360"/>
-            <a:ext cx="1389600" cy="310680"/>
+            <a:ext cx="1389240" cy="310320"/>
           </a:xfrm>
           <a:prstGeom prst="rect">
             <a:avLst/>
@@ -12191,7 +12682,7 @@
         <p:spPr>
           <a:xfrm>
             <a:off x="3867840" y="4325040"/>
-            <a:ext cx="1389600" cy="347040"/>
+            <a:ext cx="1389240" cy="346680"/>
           </a:xfrm>
           <a:prstGeom prst="rect">
             <a:avLst/>
@@ -12274,7 +12765,7 @@
         <p:spPr>
           <a:xfrm>
             <a:off x="5436000" y="3630240"/>
-            <a:ext cx="1572480" cy="1078560"/>
+            <a:ext cx="1572120" cy="1078200"/>
           </a:xfrm>
           <a:prstGeom prst="rect">
             <a:avLst/>
@@ -12300,6 +12791,11 @@
             <a:noAutofit/>
           </a:bodyPr>
           <a:p>
+            <a:pPr>
+              <a:lnSpc>
+                <a:spcPct val="100000"/>
+              </a:lnSpc>
+            </a:pPr>
             <a:endParaRPr b="0" lang="en-US" sz="1800" spc="-1" strike="noStrike">
               <a:solidFill>
                 <a:srgbClr val="ffffff"/>
@@ -12318,7 +12814,7 @@
         <p:spPr>
           <a:xfrm>
             <a:off x="5436000" y="3630240"/>
-            <a:ext cx="1572480" cy="45360"/>
+            <a:ext cx="1572120" cy="45000"/>
           </a:xfrm>
           <a:prstGeom prst="rect">
             <a:avLst/>
@@ -12344,6 +12840,11 @@
             <a:noAutofit/>
           </a:bodyPr>
           <a:p>
+            <a:pPr>
+              <a:lnSpc>
+                <a:spcPct val="100000"/>
+              </a:lnSpc>
+            </a:pPr>
             <a:endParaRPr b="0" lang="en-US" sz="1800" spc="-1" strike="noStrike">
               <a:solidFill>
                 <a:srgbClr val="000000"/>
@@ -12362,7 +12863,7 @@
         <p:spPr>
           <a:xfrm>
             <a:off x="5545800" y="3721680"/>
-            <a:ext cx="273960" cy="273960"/>
+            <a:ext cx="273600" cy="273600"/>
           </a:xfrm>
           <a:prstGeom prst="rect">
             <a:avLst/>
@@ -12419,7 +12920,7 @@
         <p:spPr>
           <a:xfrm>
             <a:off x="5545800" y="4014360"/>
-            <a:ext cx="1389600" cy="310680"/>
+            <a:ext cx="1389240" cy="310320"/>
           </a:xfrm>
           <a:prstGeom prst="rect">
             <a:avLst/>
@@ -12476,7 +12977,7 @@
         <p:spPr>
           <a:xfrm>
             <a:off x="5545800" y="4325040"/>
-            <a:ext cx="1389600" cy="347040"/>
+            <a:ext cx="1389240" cy="346680"/>
           </a:xfrm>
           <a:prstGeom prst="rect">
             <a:avLst/>
@@ -12559,7 +13060,7 @@
         <p:spPr>
           <a:xfrm>
             <a:off x="7113960" y="3630240"/>
-            <a:ext cx="1572480" cy="1078560"/>
+            <a:ext cx="1572120" cy="1078200"/>
           </a:xfrm>
           <a:prstGeom prst="rect">
             <a:avLst/>
@@ -12585,6 +13086,11 @@
             <a:noAutofit/>
           </a:bodyPr>
           <a:p>
+            <a:pPr>
+              <a:lnSpc>
+                <a:spcPct val="100000"/>
+              </a:lnSpc>
+            </a:pPr>
             <a:endParaRPr b="0" lang="en-US" sz="1800" spc="-1" strike="noStrike">
               <a:solidFill>
                 <a:srgbClr val="ffffff"/>
@@ -12603,7 +13109,7 @@
         <p:spPr>
           <a:xfrm>
             <a:off x="7113960" y="3630240"/>
-            <a:ext cx="1572480" cy="45360"/>
+            <a:ext cx="1572120" cy="45000"/>
           </a:xfrm>
           <a:prstGeom prst="rect">
             <a:avLst/>
@@ -12629,6 +13135,11 @@
             <a:noAutofit/>
           </a:bodyPr>
           <a:p>
+            <a:pPr>
+              <a:lnSpc>
+                <a:spcPct val="100000"/>
+              </a:lnSpc>
+            </a:pPr>
             <a:endParaRPr b="0" lang="en-US" sz="1800" spc="-1" strike="noStrike">
               <a:solidFill>
                 <a:srgbClr val="000000"/>
@@ -12647,7 +13158,7 @@
         <p:spPr>
           <a:xfrm>
             <a:off x="7223760" y="3721680"/>
-            <a:ext cx="273960" cy="273960"/>
+            <a:ext cx="273600" cy="273600"/>
           </a:xfrm>
           <a:prstGeom prst="rect">
             <a:avLst/>
@@ -12704,7 +13215,7 @@
         <p:spPr>
           <a:xfrm>
             <a:off x="7223760" y="4014360"/>
-            <a:ext cx="1389600" cy="310680"/>
+            <a:ext cx="1389240" cy="310320"/>
           </a:xfrm>
           <a:prstGeom prst="rect">
             <a:avLst/>
@@ -12761,7 +13272,7 @@
         <p:spPr>
           <a:xfrm>
             <a:off x="7223760" y="4325040"/>
-            <a:ext cx="1389600" cy="347040"/>
+            <a:ext cx="1389240" cy="346680"/>
           </a:xfrm>
           <a:prstGeom prst="rect">
             <a:avLst/>

</xml_diff>